<commit_message>
docs(PART_2): Replace presentation with fixed version (no empty placeholders)
</commit_message>
<xml_diff>
--- a/PART_2/Capstone-Three_Presentation.pptx
+++ b/PART_2/Capstone-Three_Presentation.pptx
@@ -5,28 +5,27 @@
     <p:sldMasterId id="2147483648" r:id="rId1"/>
   </p:sldMasterIdLst>
   <p:sldIdLst>
-    <p:sldId id="256" r:id="rId7"/>
-    <p:sldId id="257" r:id="rId8"/>
-    <p:sldId id="258" r:id="rId9"/>
-    <p:sldId id="259" r:id="rId10"/>
-    <p:sldId id="260" r:id="rId11"/>
-    <p:sldId id="261" r:id="rId12"/>
-    <p:sldId id="262" r:id="rId13"/>
-    <p:sldId id="263" r:id="rId14"/>
-    <p:sldId id="264" r:id="rId15"/>
-    <p:sldId id="265" r:id="rId16"/>
-    <p:sldId id="266" r:id="rId17"/>
-    <p:sldId id="267" r:id="rId18"/>
-    <p:sldId id="268" r:id="rId19"/>
-    <p:sldId id="269" r:id="rId20"/>
-    <p:sldId id="270" r:id="rId21"/>
-    <p:sldId id="271" r:id="rId22"/>
-    <p:sldId id="272" r:id="rId23"/>
-    <p:sldId id="273" r:id="rId24"/>
-    <p:sldId id="274" r:id="rId25"/>
-    <p:sldId id="275" r:id="rId26"/>
+    <p:sldId id="256" r:id="rId2"/>
+    <p:sldId id="257" r:id="rId3"/>
+    <p:sldId id="258" r:id="rId4"/>
+    <p:sldId id="259" r:id="rId5"/>
+    <p:sldId id="260" r:id="rId6"/>
+    <p:sldId id="261" r:id="rId7"/>
+    <p:sldId id="262" r:id="rId8"/>
+    <p:sldId id="263" r:id="rId9"/>
+    <p:sldId id="264" r:id="rId10"/>
+    <p:sldId id="265" r:id="rId11"/>
+    <p:sldId id="266" r:id="rId12"/>
+    <p:sldId id="267" r:id="rId13"/>
+    <p:sldId id="268" r:id="rId14"/>
+    <p:sldId id="269" r:id="rId15"/>
+    <p:sldId id="271" r:id="rId16"/>
+    <p:sldId id="272" r:id="rId17"/>
+    <p:sldId id="273" r:id="rId18"/>
+    <p:sldId id="274" r:id="rId19"/>
+    <p:sldId id="275" r:id="rId20"/>
   </p:sldIdLst>
-  <p:sldSz cx="12191695" cy="6858000" type="screen4x3"/>
+  <p:sldSz cx="12192000" cy="6858000"/>
   <p:notesSz cx="6858000" cy="9144000"/>
   <p:defaultTextStyle>
     <a:defPPr>
@@ -123,6 +122,22 @@
       </a:defRPr>
     </a:lvl9pPr>
   </p:defaultTextStyle>
+  <p:extLst>
+    <p:ext uri="{EFAFB233-063F-42B5-8137-9DF3F51BA10A}">
+      <p15:sldGuideLst xmlns:p15="http://schemas.microsoft.com/office/powerpoint/2012/main">
+        <p15:guide id="1" orient="horz" pos="2160">
+          <p15:clr>
+            <a:srgbClr val="A4A3A4"/>
+          </p15:clr>
+        </p15:guide>
+        <p15:guide id="2" pos="2880">
+          <p15:clr>
+            <a:srgbClr val="A4A3A4"/>
+          </p15:clr>
+        </p15:guide>
+      </p15:sldGuideLst>
+    </p:ext>
+  </p:extLst>
 </p:presentation>
 </file>
 
@@ -164,10 +179,9 @@
           <a:lstStyle/>
           <a:p>
             <a:r>
-              <a:rPr lang="en-US" smtClean="0"/>
+              <a:rPr lang="en-US"/>
               <a:t>Click to edit Master title style</a:t>
             </a:r>
-            <a:endParaRPr lang="en-US"/>
           </a:p>
         </p:txBody>
       </p:sp>
@@ -283,10 +297,9 @@
           </a:lstStyle>
           <a:p>
             <a:r>
-              <a:rPr lang="en-US" smtClean="0"/>
+              <a:rPr lang="en-US"/>
               <a:t>Click to edit Master subtitle style</a:t>
             </a:r>
-            <a:endParaRPr lang="en-US"/>
           </a:p>
         </p:txBody>
       </p:sp>
@@ -307,7 +320,7 @@
           <a:p>
             <a:fld id="{5BCAD085-E8A6-8845-BD4E-CB4CCA059FC4}" type="datetimeFigureOut">
               <a:rPr lang="en-US" smtClean="0"/>
-              <a:t>1/27/13</a:t>
+              <a:t>6/6/2026</a:t>
             </a:fld>
             <a:endParaRPr lang="en-US"/>
           </a:p>
@@ -401,10 +414,9 @@
           <a:lstStyle/>
           <a:p>
             <a:r>
-              <a:rPr lang="en-US" smtClean="0"/>
+              <a:rPr lang="en-US"/>
               <a:t>Click to edit Master title style</a:t>
             </a:r>
-            <a:endParaRPr lang="en-US"/>
           </a:p>
         </p:txBody>
       </p:sp>
@@ -425,38 +437,37 @@
           <a:p>
             <a:pPr lvl="0"/>
             <a:r>
-              <a:rPr lang="en-US" smtClean="0"/>
+              <a:rPr lang="en-US"/>
               <a:t>Click to edit Master text styles</a:t>
             </a:r>
           </a:p>
           <a:p>
             <a:pPr lvl="1"/>
             <a:r>
-              <a:rPr lang="en-US" smtClean="0"/>
+              <a:rPr lang="en-US"/>
               <a:t>Second level</a:t>
             </a:r>
           </a:p>
           <a:p>
             <a:pPr lvl="2"/>
             <a:r>
-              <a:rPr lang="en-US" smtClean="0"/>
+              <a:rPr lang="en-US"/>
               <a:t>Third level</a:t>
             </a:r>
           </a:p>
           <a:p>
             <a:pPr lvl="3"/>
             <a:r>
-              <a:rPr lang="en-US" smtClean="0"/>
+              <a:rPr lang="en-US"/>
               <a:t>Fourth level</a:t>
             </a:r>
           </a:p>
           <a:p>
             <a:pPr lvl="4"/>
             <a:r>
-              <a:rPr lang="en-US" smtClean="0"/>
+              <a:rPr lang="en-US"/>
               <a:t>Fifth level</a:t>
             </a:r>
-            <a:endParaRPr lang="en-US"/>
           </a:p>
         </p:txBody>
       </p:sp>
@@ -477,7 +488,7 @@
           <a:p>
             <a:fld id="{5BCAD085-E8A6-8845-BD4E-CB4CCA059FC4}" type="datetimeFigureOut">
               <a:rPr lang="en-US" smtClean="0"/>
-              <a:t>1/27/13</a:t>
+              <a:t>6/6/2026</a:t>
             </a:fld>
             <a:endParaRPr lang="en-US"/>
           </a:p>
@@ -576,10 +587,9 @@
           <a:lstStyle/>
           <a:p>
             <a:r>
-              <a:rPr lang="en-US" smtClean="0"/>
+              <a:rPr lang="en-US"/>
               <a:t>Click to edit Master title style</a:t>
             </a:r>
-            <a:endParaRPr lang="en-US"/>
           </a:p>
         </p:txBody>
       </p:sp>
@@ -605,38 +615,37 @@
           <a:p>
             <a:pPr lvl="0"/>
             <a:r>
-              <a:rPr lang="en-US" smtClean="0"/>
+              <a:rPr lang="en-US"/>
               <a:t>Click to edit Master text styles</a:t>
             </a:r>
           </a:p>
           <a:p>
             <a:pPr lvl="1"/>
             <a:r>
-              <a:rPr lang="en-US" smtClean="0"/>
+              <a:rPr lang="en-US"/>
               <a:t>Second level</a:t>
             </a:r>
           </a:p>
           <a:p>
             <a:pPr lvl="2"/>
             <a:r>
-              <a:rPr lang="en-US" smtClean="0"/>
+              <a:rPr lang="en-US"/>
               <a:t>Third level</a:t>
             </a:r>
           </a:p>
           <a:p>
             <a:pPr lvl="3"/>
             <a:r>
-              <a:rPr lang="en-US" smtClean="0"/>
+              <a:rPr lang="en-US"/>
               <a:t>Fourth level</a:t>
             </a:r>
           </a:p>
           <a:p>
             <a:pPr lvl="4"/>
             <a:r>
-              <a:rPr lang="en-US" smtClean="0"/>
+              <a:rPr lang="en-US"/>
               <a:t>Fifth level</a:t>
             </a:r>
-            <a:endParaRPr lang="en-US"/>
           </a:p>
         </p:txBody>
       </p:sp>
@@ -657,7 +666,7 @@
           <a:p>
             <a:fld id="{5BCAD085-E8A6-8845-BD4E-CB4CCA059FC4}" type="datetimeFigureOut">
               <a:rPr lang="en-US" smtClean="0"/>
-              <a:t>1/27/13</a:t>
+              <a:t>6/6/2026</a:t>
             </a:fld>
             <a:endParaRPr lang="en-US"/>
           </a:p>
@@ -751,10 +760,9 @@
           <a:lstStyle/>
           <a:p>
             <a:r>
-              <a:rPr lang="en-US" smtClean="0"/>
+              <a:rPr lang="en-US"/>
               <a:t>Click to edit Master title style</a:t>
             </a:r>
-            <a:endParaRPr lang="en-US"/>
           </a:p>
         </p:txBody>
       </p:sp>
@@ -775,38 +783,37 @@
           <a:p>
             <a:pPr lvl="0"/>
             <a:r>
-              <a:rPr lang="en-US" smtClean="0"/>
+              <a:rPr lang="en-US"/>
               <a:t>Click to edit Master text styles</a:t>
             </a:r>
           </a:p>
           <a:p>
             <a:pPr lvl="1"/>
             <a:r>
-              <a:rPr lang="en-US" smtClean="0"/>
+              <a:rPr lang="en-US"/>
               <a:t>Second level</a:t>
             </a:r>
           </a:p>
           <a:p>
             <a:pPr lvl="2"/>
             <a:r>
-              <a:rPr lang="en-US" smtClean="0"/>
+              <a:rPr lang="en-US"/>
               <a:t>Third level</a:t>
             </a:r>
           </a:p>
           <a:p>
             <a:pPr lvl="3"/>
             <a:r>
-              <a:rPr lang="en-US" smtClean="0"/>
+              <a:rPr lang="en-US"/>
               <a:t>Fourth level</a:t>
             </a:r>
           </a:p>
           <a:p>
             <a:pPr lvl="4"/>
             <a:r>
-              <a:rPr lang="en-US" smtClean="0"/>
+              <a:rPr lang="en-US"/>
               <a:t>Fifth level</a:t>
             </a:r>
-            <a:endParaRPr lang="en-US"/>
           </a:p>
         </p:txBody>
       </p:sp>
@@ -827,7 +834,7 @@
           <a:p>
             <a:fld id="{5BCAD085-E8A6-8845-BD4E-CB4CCA059FC4}" type="datetimeFigureOut">
               <a:rPr lang="en-US" smtClean="0"/>
-              <a:t>1/27/13</a:t>
+              <a:t>6/6/2026</a:t>
             </a:fld>
             <a:endParaRPr lang="en-US"/>
           </a:p>
@@ -930,10 +937,9 @@
           </a:lstStyle>
           <a:p>
             <a:r>
-              <a:rPr lang="en-US" smtClean="0"/>
+              <a:rPr lang="en-US"/>
               <a:t>Click to edit Master title style</a:t>
             </a:r>
-            <a:endParaRPr lang="en-US"/>
           </a:p>
         </p:txBody>
       </p:sp>
@@ -1050,7 +1056,7 @@
           <a:p>
             <a:pPr lvl="0"/>
             <a:r>
-              <a:rPr lang="en-US" smtClean="0"/>
+              <a:rPr lang="en-US"/>
               <a:t>Click to edit Master text styles</a:t>
             </a:r>
           </a:p>
@@ -1073,7 +1079,7 @@
           <a:p>
             <a:fld id="{5BCAD085-E8A6-8845-BD4E-CB4CCA059FC4}" type="datetimeFigureOut">
               <a:rPr lang="en-US" smtClean="0"/>
-              <a:t>1/27/13</a:t>
+              <a:t>6/6/2026</a:t>
             </a:fld>
             <a:endParaRPr lang="en-US"/>
           </a:p>
@@ -1167,10 +1173,9 @@
           <a:lstStyle/>
           <a:p>
             <a:r>
-              <a:rPr lang="en-US" smtClean="0"/>
+              <a:rPr lang="en-US"/>
               <a:t>Click to edit Master title style</a:t>
             </a:r>
-            <a:endParaRPr lang="en-US"/>
           </a:p>
         </p:txBody>
       </p:sp>
@@ -1224,38 +1229,37 @@
           <a:p>
             <a:pPr lvl="0"/>
             <a:r>
-              <a:rPr lang="en-US" smtClean="0"/>
+              <a:rPr lang="en-US"/>
               <a:t>Click to edit Master text styles</a:t>
             </a:r>
           </a:p>
           <a:p>
             <a:pPr lvl="1"/>
             <a:r>
-              <a:rPr lang="en-US" smtClean="0"/>
+              <a:rPr lang="en-US"/>
               <a:t>Second level</a:t>
             </a:r>
           </a:p>
           <a:p>
             <a:pPr lvl="2"/>
             <a:r>
-              <a:rPr lang="en-US" smtClean="0"/>
+              <a:rPr lang="en-US"/>
               <a:t>Third level</a:t>
             </a:r>
           </a:p>
           <a:p>
             <a:pPr lvl="3"/>
             <a:r>
-              <a:rPr lang="en-US" smtClean="0"/>
+              <a:rPr lang="en-US"/>
               <a:t>Fourth level</a:t>
             </a:r>
           </a:p>
           <a:p>
             <a:pPr lvl="4"/>
             <a:r>
-              <a:rPr lang="en-US" smtClean="0"/>
+              <a:rPr lang="en-US"/>
               <a:t>Fifth level</a:t>
             </a:r>
-            <a:endParaRPr lang="en-US"/>
           </a:p>
         </p:txBody>
       </p:sp>
@@ -1309,38 +1313,37 @@
           <a:p>
             <a:pPr lvl="0"/>
             <a:r>
-              <a:rPr lang="en-US" smtClean="0"/>
+              <a:rPr lang="en-US"/>
               <a:t>Click to edit Master text styles</a:t>
             </a:r>
           </a:p>
           <a:p>
             <a:pPr lvl="1"/>
             <a:r>
-              <a:rPr lang="en-US" smtClean="0"/>
+              <a:rPr lang="en-US"/>
               <a:t>Second level</a:t>
             </a:r>
           </a:p>
           <a:p>
             <a:pPr lvl="2"/>
             <a:r>
-              <a:rPr lang="en-US" smtClean="0"/>
+              <a:rPr lang="en-US"/>
               <a:t>Third level</a:t>
             </a:r>
           </a:p>
           <a:p>
             <a:pPr lvl="3"/>
             <a:r>
-              <a:rPr lang="en-US" smtClean="0"/>
+              <a:rPr lang="en-US"/>
               <a:t>Fourth level</a:t>
             </a:r>
           </a:p>
           <a:p>
             <a:pPr lvl="4"/>
             <a:r>
-              <a:rPr lang="en-US" smtClean="0"/>
+              <a:rPr lang="en-US"/>
               <a:t>Fifth level</a:t>
             </a:r>
-            <a:endParaRPr lang="en-US"/>
           </a:p>
         </p:txBody>
       </p:sp>
@@ -1361,7 +1364,7 @@
           <a:p>
             <a:fld id="{5BCAD085-E8A6-8845-BD4E-CB4CCA059FC4}" type="datetimeFigureOut">
               <a:rPr lang="en-US" smtClean="0"/>
-              <a:t>1/27/13</a:t>
+              <a:t>6/6/2026</a:t>
             </a:fld>
             <a:endParaRPr lang="en-US"/>
           </a:p>
@@ -1459,10 +1462,9 @@
           </a:lstStyle>
           <a:p>
             <a:r>
-              <a:rPr lang="en-US" smtClean="0"/>
+              <a:rPr lang="en-US"/>
               <a:t>Click to edit Master title style</a:t>
             </a:r>
-            <a:endParaRPr lang="en-US"/>
           </a:p>
         </p:txBody>
       </p:sp>
@@ -1525,7 +1527,7 @@
           <a:p>
             <a:pPr lvl="0"/>
             <a:r>
-              <a:rPr lang="en-US" smtClean="0"/>
+              <a:rPr lang="en-US"/>
               <a:t>Click to edit Master text styles</a:t>
             </a:r>
           </a:p>
@@ -1581,38 +1583,37 @@
           <a:p>
             <a:pPr lvl="0"/>
             <a:r>
-              <a:rPr lang="en-US" smtClean="0"/>
+              <a:rPr lang="en-US"/>
               <a:t>Click to edit Master text styles</a:t>
             </a:r>
           </a:p>
           <a:p>
             <a:pPr lvl="1"/>
             <a:r>
-              <a:rPr lang="en-US" smtClean="0"/>
+              <a:rPr lang="en-US"/>
               <a:t>Second level</a:t>
             </a:r>
           </a:p>
           <a:p>
             <a:pPr lvl="2"/>
             <a:r>
-              <a:rPr lang="en-US" smtClean="0"/>
+              <a:rPr lang="en-US"/>
               <a:t>Third level</a:t>
             </a:r>
           </a:p>
           <a:p>
             <a:pPr lvl="3"/>
             <a:r>
-              <a:rPr lang="en-US" smtClean="0"/>
+              <a:rPr lang="en-US"/>
               <a:t>Fourth level</a:t>
             </a:r>
           </a:p>
           <a:p>
             <a:pPr lvl="4"/>
             <a:r>
-              <a:rPr lang="en-US" smtClean="0"/>
+              <a:rPr lang="en-US"/>
               <a:t>Fifth level</a:t>
             </a:r>
-            <a:endParaRPr lang="en-US"/>
           </a:p>
         </p:txBody>
       </p:sp>
@@ -1675,7 +1676,7 @@
           <a:p>
             <a:pPr lvl="0"/>
             <a:r>
-              <a:rPr lang="en-US" smtClean="0"/>
+              <a:rPr lang="en-US"/>
               <a:t>Click to edit Master text styles</a:t>
             </a:r>
           </a:p>
@@ -1731,38 +1732,37 @@
           <a:p>
             <a:pPr lvl="0"/>
             <a:r>
-              <a:rPr lang="en-US" smtClean="0"/>
+              <a:rPr lang="en-US"/>
               <a:t>Click to edit Master text styles</a:t>
             </a:r>
           </a:p>
           <a:p>
             <a:pPr lvl="1"/>
             <a:r>
-              <a:rPr lang="en-US" smtClean="0"/>
+              <a:rPr lang="en-US"/>
               <a:t>Second level</a:t>
             </a:r>
           </a:p>
           <a:p>
             <a:pPr lvl="2"/>
             <a:r>
-              <a:rPr lang="en-US" smtClean="0"/>
+              <a:rPr lang="en-US"/>
               <a:t>Third level</a:t>
             </a:r>
           </a:p>
           <a:p>
             <a:pPr lvl="3"/>
             <a:r>
-              <a:rPr lang="en-US" smtClean="0"/>
+              <a:rPr lang="en-US"/>
               <a:t>Fourth level</a:t>
             </a:r>
           </a:p>
           <a:p>
             <a:pPr lvl="4"/>
             <a:r>
-              <a:rPr lang="en-US" smtClean="0"/>
+              <a:rPr lang="en-US"/>
               <a:t>Fifth level</a:t>
             </a:r>
-            <a:endParaRPr lang="en-US"/>
           </a:p>
         </p:txBody>
       </p:sp>
@@ -1783,7 +1783,7 @@
           <a:p>
             <a:fld id="{5BCAD085-E8A6-8845-BD4E-CB4CCA059FC4}" type="datetimeFigureOut">
               <a:rPr lang="en-US" smtClean="0"/>
-              <a:t>1/27/13</a:t>
+              <a:t>6/6/2026</a:t>
             </a:fld>
             <a:endParaRPr lang="en-US"/>
           </a:p>
@@ -1877,10 +1877,9 @@
           <a:lstStyle/>
           <a:p>
             <a:r>
-              <a:rPr lang="en-US" smtClean="0"/>
+              <a:rPr lang="en-US"/>
               <a:t>Click to edit Master title style</a:t>
             </a:r>
-            <a:endParaRPr lang="en-US"/>
           </a:p>
         </p:txBody>
       </p:sp>
@@ -1901,7 +1900,7 @@
           <a:p>
             <a:fld id="{5BCAD085-E8A6-8845-BD4E-CB4CCA059FC4}" type="datetimeFigureOut">
               <a:rPr lang="en-US" smtClean="0"/>
-              <a:t>1/27/13</a:t>
+              <a:t>6/6/2026</a:t>
             </a:fld>
             <a:endParaRPr lang="en-US"/>
           </a:p>
@@ -1996,7 +1995,7 @@
           <a:p>
             <a:fld id="{5BCAD085-E8A6-8845-BD4E-CB4CCA059FC4}" type="datetimeFigureOut">
               <a:rPr lang="en-US" smtClean="0"/>
-              <a:t>1/27/13</a:t>
+              <a:t>6/6/2026</a:t>
             </a:fld>
             <a:endParaRPr lang="en-US"/>
           </a:p>
@@ -2099,10 +2098,9 @@
           </a:lstStyle>
           <a:p>
             <a:r>
-              <a:rPr lang="en-US" smtClean="0"/>
+              <a:rPr lang="en-US"/>
               <a:t>Click to edit Master title style</a:t>
             </a:r>
-            <a:endParaRPr lang="en-US"/>
           </a:p>
         </p:txBody>
       </p:sp>
@@ -2156,38 +2154,37 @@
           <a:p>
             <a:pPr lvl="0"/>
             <a:r>
-              <a:rPr lang="en-US" smtClean="0"/>
+              <a:rPr lang="en-US"/>
               <a:t>Click to edit Master text styles</a:t>
             </a:r>
           </a:p>
           <a:p>
             <a:pPr lvl="1"/>
             <a:r>
-              <a:rPr lang="en-US" smtClean="0"/>
+              <a:rPr lang="en-US"/>
               <a:t>Second level</a:t>
             </a:r>
           </a:p>
           <a:p>
             <a:pPr lvl="2"/>
             <a:r>
-              <a:rPr lang="en-US" smtClean="0"/>
+              <a:rPr lang="en-US"/>
               <a:t>Third level</a:t>
             </a:r>
           </a:p>
           <a:p>
             <a:pPr lvl="3"/>
             <a:r>
-              <a:rPr lang="en-US" smtClean="0"/>
+              <a:rPr lang="en-US"/>
               <a:t>Fourth level</a:t>
             </a:r>
           </a:p>
           <a:p>
             <a:pPr lvl="4"/>
             <a:r>
-              <a:rPr lang="en-US" smtClean="0"/>
+              <a:rPr lang="en-US"/>
               <a:t>Fifth level</a:t>
             </a:r>
-            <a:endParaRPr lang="en-US"/>
           </a:p>
         </p:txBody>
       </p:sp>
@@ -2250,7 +2247,7 @@
           <a:p>
             <a:pPr lvl="0"/>
             <a:r>
-              <a:rPr lang="en-US" smtClean="0"/>
+              <a:rPr lang="en-US"/>
               <a:t>Click to edit Master text styles</a:t>
             </a:r>
           </a:p>
@@ -2273,7 +2270,7 @@
           <a:p>
             <a:fld id="{5BCAD085-E8A6-8845-BD4E-CB4CCA059FC4}" type="datetimeFigureOut">
               <a:rPr lang="en-US" smtClean="0"/>
-              <a:t>1/27/13</a:t>
+              <a:t>6/6/2026</a:t>
             </a:fld>
             <a:endParaRPr lang="en-US"/>
           </a:p>
@@ -2376,10 +2373,9 @@
           </a:lstStyle>
           <a:p>
             <a:r>
-              <a:rPr lang="en-US" smtClean="0"/>
+              <a:rPr lang="en-US"/>
               <a:t>Click to edit Master title style</a:t>
             </a:r>
-            <a:endParaRPr lang="en-US"/>
           </a:p>
         </p:txBody>
       </p:sp>
@@ -2503,7 +2499,7 @@
           <a:p>
             <a:pPr lvl="0"/>
             <a:r>
-              <a:rPr lang="en-US" smtClean="0"/>
+              <a:rPr lang="en-US"/>
               <a:t>Click to edit Master text styles</a:t>
             </a:r>
           </a:p>
@@ -2526,7 +2522,7 @@
           <a:p>
             <a:fld id="{5BCAD085-E8A6-8845-BD4E-CB4CCA059FC4}" type="datetimeFigureOut">
               <a:rPr lang="en-US" smtClean="0"/>
-              <a:t>1/27/13</a:t>
+              <a:t>6/6/2026</a:t>
             </a:fld>
             <a:endParaRPr lang="en-US"/>
           </a:p>
@@ -2635,10 +2631,9 @@
           <a:lstStyle/>
           <a:p>
             <a:r>
-              <a:rPr lang="en-US" smtClean="0"/>
+              <a:rPr lang="en-US"/>
               <a:t>Click to edit Master title style</a:t>
             </a:r>
-            <a:endParaRPr lang="en-US"/>
           </a:p>
         </p:txBody>
       </p:sp>
@@ -2669,38 +2664,37 @@
           <a:p>
             <a:pPr lvl="0"/>
             <a:r>
-              <a:rPr lang="en-US" smtClean="0"/>
+              <a:rPr lang="en-US"/>
               <a:t>Click to edit Master text styles</a:t>
             </a:r>
           </a:p>
           <a:p>
             <a:pPr lvl="1"/>
             <a:r>
-              <a:rPr lang="en-US" smtClean="0"/>
+              <a:rPr lang="en-US"/>
               <a:t>Second level</a:t>
             </a:r>
           </a:p>
           <a:p>
             <a:pPr lvl="2"/>
             <a:r>
-              <a:rPr lang="en-US" smtClean="0"/>
+              <a:rPr lang="en-US"/>
               <a:t>Third level</a:t>
             </a:r>
           </a:p>
           <a:p>
             <a:pPr lvl="3"/>
             <a:r>
-              <a:rPr lang="en-US" smtClean="0"/>
+              <a:rPr lang="en-US"/>
               <a:t>Fourth level</a:t>
             </a:r>
           </a:p>
           <a:p>
             <a:pPr lvl="4"/>
             <a:r>
-              <a:rPr lang="en-US" smtClean="0"/>
+              <a:rPr lang="en-US"/>
               <a:t>Fifth level</a:t>
             </a:r>
-            <a:endParaRPr lang="en-US"/>
           </a:p>
         </p:txBody>
       </p:sp>
@@ -2739,7 +2733,7 @@
           <a:p>
             <a:fld id="{5BCAD085-E8A6-8845-BD4E-CB4CCA059FC4}" type="datetimeFigureOut">
               <a:rPr lang="en-US" smtClean="0"/>
-              <a:t>1/27/13</a:t>
+              <a:t>6/6/2026</a:t>
             </a:fld>
             <a:endParaRPr lang="en-US"/>
           </a:p>
@@ -3098,7 +3092,7 @@
 </file>
 
 <file path=ppt/slides/slide1.xml><?xml version="1.0" encoding="utf-8"?>
-<p:sld xmlns:a="http://schemas.openxmlformats.org/drawingml/2006/main" xmlns:p="http://schemas.openxmlformats.org/presentationml/2006/main" xmlns:r="http://schemas.openxmlformats.org/officeDocument/2006/relationships">
+<p:sld xmlns:a="http://schemas.openxmlformats.org/drawingml/2006/main" xmlns:r="http://schemas.openxmlformats.org/officeDocument/2006/relationships" xmlns:p="http://schemas.openxmlformats.org/presentationml/2006/main">
   <p:cSld>
     <p:spTree>
       <p:nvGrpSpPr>
@@ -3106,24 +3100,14 @@
         <p:cNvGrpSpPr/>
         <p:nvPr/>
       </p:nvGrpSpPr>
-      <p:grpSpPr/>
-      <p:sp>
-        <p:nvSpPr>
-          <p:cNvPr id="2" name="Title 1"/>
-          <p:cNvSpPr>
-            <a:spLocks noGrp="1"/>
-          </p:cNvSpPr>
-          <p:nvPr>
-            <p:ph type="title"/>
-          </p:nvPr>
-        </p:nvSpPr>
-        <p:spPr/>
-        <p:txBody>
-          <a:bodyPr/>
-          <a:lstStyle/>
-          <a:p/>
-        </p:txBody>
-      </p:sp>
+      <p:grpSpPr>
+        <a:xfrm>
+          <a:off x="0" y="0"/>
+          <a:ext cx="0" cy="0"/>
+          <a:chOff x="0" y="0"/>
+          <a:chExt cx="0" cy="0"/>
+        </a:xfrm>
+      </p:grpSpPr>
       <p:sp>
         <p:nvSpPr>
           <p:cNvPr id="3" name="TextBox 2"/>
@@ -3141,7 +3125,7 @@
           <a:noFill/>
         </p:spPr>
         <p:txBody>
-          <a:bodyPr wrap="none">
+          <a:bodyPr wrap="square">
             <a:spAutoFit/>
           </a:bodyPr>
           <a:lstStyle/>
@@ -3169,7 +3153,9 @@
               <a:t>Data Augmentation for Glaucoma Detection</a:t>
             </a:r>
           </a:p>
-          <a:p/>
+          <a:p>
+            <a:endParaRPr/>
+          </a:p>
           <a:p>
             <a:pPr algn="ctr">
               <a:defRPr sz="2000">
@@ -3193,7 +3179,7 @@
 </file>
 
 <file path=ppt/slides/slide10.xml><?xml version="1.0" encoding="utf-8"?>
-<p:sld xmlns:a="http://schemas.openxmlformats.org/drawingml/2006/main" xmlns:p="http://schemas.openxmlformats.org/presentationml/2006/main" xmlns:r="http://schemas.openxmlformats.org/officeDocument/2006/relationships">
+<p:sld xmlns:a="http://schemas.openxmlformats.org/drawingml/2006/main" xmlns:r="http://schemas.openxmlformats.org/officeDocument/2006/relationships" xmlns:p="http://schemas.openxmlformats.org/presentationml/2006/main">
   <p:cSld>
     <p:spTree>
       <p:nvGrpSpPr>
@@ -3201,24 +3187,14 @@
         <p:cNvGrpSpPr/>
         <p:nvPr/>
       </p:nvGrpSpPr>
-      <p:grpSpPr/>
-      <p:sp>
-        <p:nvSpPr>
-          <p:cNvPr id="2" name="Title 1"/>
-          <p:cNvSpPr>
-            <a:spLocks noGrp="1"/>
-          </p:cNvSpPr>
-          <p:nvPr>
-            <p:ph type="title"/>
-          </p:nvPr>
-        </p:nvSpPr>
-        <p:spPr/>
-        <p:txBody>
-          <a:bodyPr/>
-          <a:lstStyle/>
-          <a:p/>
-        </p:txBody>
-      </p:sp>
+      <p:grpSpPr>
+        <a:xfrm>
+          <a:off x="0" y="0"/>
+          <a:ext cx="0" cy="0"/>
+          <a:chOff x="0" y="0"/>
+          <a:chExt cx="0" cy="0"/>
+        </a:xfrm>
+      </p:grpSpPr>
       <p:sp>
         <p:nvSpPr>
           <p:cNvPr id="3" name="TextBox 2"/>
@@ -3263,7 +3239,7 @@
         <p:spPr>
           <a:xfrm>
             <a:off x="457200" y="1371600"/>
-            <a:ext cx="10972800" cy="5029200"/>
+            <a:ext cx="10972800" cy="4293483"/>
           </a:xfrm>
           <a:prstGeom prst="rect">
             <a:avLst/>
@@ -3283,17 +3259,27 @@
               <a:defRPr sz="1800"/>
             </a:pPr>
             <a:r>
-              <a:t>• Optimizer: NAdam (LR = 1e-4, tuned via grid search)</a:t>
-            </a:r>
-          </a:p>
-          <a:p>
-            <a:pPr>
-              <a:spcAft>
-                <a:spcPts val="1000"/>
-              </a:spcAft>
-              <a:defRPr sz="1800"/>
-            </a:pPr>
-            <a:r>
+              <a:rPr sz="2000" dirty="0"/>
+              <a:t>• Optimizer: </a:t>
+            </a:r>
+            <a:r>
+              <a:rPr sz="2000" dirty="0" err="1"/>
+              <a:t>NAdam</a:t>
+            </a:r>
+            <a:r>
+              <a:rPr sz="2000" dirty="0"/>
+              <a:t> (LR = 1e-4, tuned via grid search)</a:t>
+            </a:r>
+          </a:p>
+          <a:p>
+            <a:pPr>
+              <a:spcAft>
+                <a:spcPts val="1000"/>
+              </a:spcAft>
+              <a:defRPr sz="1800"/>
+            </a:pPr>
+            <a:r>
+              <a:rPr sz="2000" dirty="0"/>
               <a:t>• Batch size: 4</a:t>
             </a:r>
           </a:p>
@@ -3305,17 +3291,24 @@
               <a:defRPr sz="1800"/>
             </a:pPr>
             <a:r>
-              <a:t>• Early stopping: patience=5, monitor val_auc</a:t>
-            </a:r>
-          </a:p>
-          <a:p>
-            <a:pPr>
-              <a:spcAft>
-                <a:spcPts val="1000"/>
-              </a:spcAft>
-              <a:defRPr sz="1800"/>
-            </a:pPr>
-            <a:r>
+              <a:rPr sz="2000" dirty="0"/>
+              <a:t>• Early stopping: patience=5, monitor </a:t>
+            </a:r>
+            <a:r>
+              <a:rPr sz="2000" dirty="0" err="1"/>
+              <a:t>val_auc</a:t>
+            </a:r>
+            <a:endParaRPr sz="2000" dirty="0"/>
+          </a:p>
+          <a:p>
+            <a:pPr>
+              <a:spcAft>
+                <a:spcPts val="1000"/>
+              </a:spcAft>
+              <a:defRPr sz="1800"/>
+            </a:pPr>
+            <a:r>
+              <a:rPr sz="2000" dirty="0"/>
               <a:t>• Input normalization: /255 to [0, 1]</a:t>
             </a:r>
           </a:p>
@@ -3327,6 +3320,7 @@
               <a:defRPr sz="1800"/>
             </a:pPr>
             <a:r>
+              <a:rPr sz="2000" dirty="0"/>
               <a:t>• Training data: 5,328 augmented volumes (6× originals)</a:t>
             </a:r>
           </a:p>
@@ -3338,6 +3332,7 @@
               <a:defRPr sz="1800"/>
             </a:pPr>
             <a:r>
+              <a:rPr sz="2000" dirty="0"/>
               <a:t>• Validation: 111 original volumes</a:t>
             </a:r>
           </a:p>
@@ -3349,6 +3344,7 @@
               <a:defRPr sz="1800"/>
             </a:pPr>
             <a:r>
+              <a:rPr sz="2000" dirty="0"/>
               <a:t>• Evaluation: 111 original volumes (fair comparison)</a:t>
             </a:r>
           </a:p>
@@ -3359,15 +3355,17 @@
               </a:spcAft>
               <a:defRPr sz="1800"/>
             </a:pPr>
-          </a:p>
-          <a:p>
-            <a:pPr>
-              <a:spcAft>
-                <a:spcPts val="1000"/>
-              </a:spcAft>
-              <a:defRPr sz="1800"/>
-            </a:pPr>
-            <a:r>
+            <a:endParaRPr sz="2000" dirty="0"/>
+          </a:p>
+          <a:p>
+            <a:pPr>
+              <a:spcAft>
+                <a:spcPts val="1000"/>
+              </a:spcAft>
+              <a:defRPr sz="1800"/>
+            </a:pPr>
+            <a:r>
+              <a:rPr sz="2000" dirty="0"/>
               <a:t>• NO class balancing (Part 1 showed this hurts)</a:t>
             </a:r>
           </a:p>
@@ -3379,6 +3377,7 @@
               <a:defRPr sz="1800"/>
             </a:pPr>
             <a:r>
+              <a:rPr sz="2000" dirty="0"/>
               <a:t>• NO stratification (paper never used it)</a:t>
             </a:r>
           </a:p>
@@ -3393,7 +3392,7 @@
 </file>
 
 <file path=ppt/slides/slide11.xml><?xml version="1.0" encoding="utf-8"?>
-<p:sld xmlns:a="http://schemas.openxmlformats.org/drawingml/2006/main" xmlns:p="http://schemas.openxmlformats.org/presentationml/2006/main" xmlns:r="http://schemas.openxmlformats.org/officeDocument/2006/relationships">
+<p:sld xmlns:a="http://schemas.openxmlformats.org/drawingml/2006/main" xmlns:r="http://schemas.openxmlformats.org/officeDocument/2006/relationships" xmlns:p="http://schemas.openxmlformats.org/presentationml/2006/main">
   <p:cSld>
     <p:spTree>
       <p:nvGrpSpPr>
@@ -3401,24 +3400,14 @@
         <p:cNvGrpSpPr/>
         <p:nvPr/>
       </p:nvGrpSpPr>
-      <p:grpSpPr/>
-      <p:sp>
-        <p:nvSpPr>
-          <p:cNvPr id="2" name="Title 1"/>
-          <p:cNvSpPr>
-            <a:spLocks noGrp="1"/>
-          </p:cNvSpPr>
-          <p:nvPr>
-            <p:ph type="title"/>
-          </p:nvPr>
-        </p:nvSpPr>
-        <p:spPr/>
-        <p:txBody>
-          <a:bodyPr/>
-          <a:lstStyle/>
-          <a:p/>
-        </p:txBody>
-      </p:sp>
+      <p:grpSpPr>
+        <a:xfrm>
+          <a:off x="0" y="0"/>
+          <a:ext cx="0" cy="0"/>
+          <a:chOff x="0" y="0"/>
+          <a:chExt cx="0" cy="0"/>
+        </a:xfrm>
+      </p:grpSpPr>
       <p:sp>
         <p:nvSpPr>
           <p:cNvPr id="3" name="TextBox 2"/>
@@ -3471,7 +3460,7 @@
         <p:spPr>
           <a:xfrm>
             <a:off x="1371600" y="1371600"/>
-            <a:ext cx="9144000" cy="5678254"/>
+            <a:ext cx="9144000" cy="5212080"/>
           </a:xfrm>
           <a:prstGeom prst="rect">
             <a:avLst/>
@@ -3487,7 +3476,7 @@
 </file>
 
 <file path=ppt/slides/slide12.xml><?xml version="1.0" encoding="utf-8"?>
-<p:sld xmlns:a="http://schemas.openxmlformats.org/drawingml/2006/main" xmlns:p="http://schemas.openxmlformats.org/presentationml/2006/main" xmlns:r="http://schemas.openxmlformats.org/officeDocument/2006/relationships">
+<p:sld xmlns:a="http://schemas.openxmlformats.org/drawingml/2006/main" xmlns:r="http://schemas.openxmlformats.org/officeDocument/2006/relationships" xmlns:p="http://schemas.openxmlformats.org/presentationml/2006/main">
   <p:cSld>
     <p:spTree>
       <p:nvGrpSpPr>
@@ -3495,24 +3484,14 @@
         <p:cNvGrpSpPr/>
         <p:nvPr/>
       </p:nvGrpSpPr>
-      <p:grpSpPr/>
-      <p:sp>
-        <p:nvSpPr>
-          <p:cNvPr id="2" name="Title 1"/>
-          <p:cNvSpPr>
-            <a:spLocks noGrp="1"/>
-          </p:cNvSpPr>
-          <p:nvPr>
-            <p:ph type="title"/>
-          </p:nvPr>
-        </p:nvSpPr>
-        <p:spPr/>
-        <p:txBody>
-          <a:bodyPr/>
-          <a:lstStyle/>
-          <a:p/>
-        </p:txBody>
-      </p:sp>
+      <p:grpSpPr>
+        <a:xfrm>
+          <a:off x="0" y="0"/>
+          <a:ext cx="0" cy="0"/>
+          <a:chOff x="0" y="0"/>
+          <a:chExt cx="0" cy="0"/>
+        </a:xfrm>
+      </p:grpSpPr>
       <p:sp>
         <p:nvSpPr>
           <p:cNvPr id="3" name="TextBox 2"/>
@@ -3581,7 +3560,7 @@
 </file>
 
 <file path=ppt/slides/slide13.xml><?xml version="1.0" encoding="utf-8"?>
-<p:sld xmlns:a="http://schemas.openxmlformats.org/drawingml/2006/main" xmlns:p="http://schemas.openxmlformats.org/presentationml/2006/main" xmlns:r="http://schemas.openxmlformats.org/officeDocument/2006/relationships">
+<p:sld xmlns:a="http://schemas.openxmlformats.org/drawingml/2006/main" xmlns:r="http://schemas.openxmlformats.org/officeDocument/2006/relationships" xmlns:p="http://schemas.openxmlformats.org/presentationml/2006/main">
   <p:cSld>
     <p:spTree>
       <p:nvGrpSpPr>
@@ -3589,24 +3568,14 @@
         <p:cNvGrpSpPr/>
         <p:nvPr/>
       </p:nvGrpSpPr>
-      <p:grpSpPr/>
-      <p:sp>
-        <p:nvSpPr>
-          <p:cNvPr id="2" name="Title 1"/>
-          <p:cNvSpPr>
-            <a:spLocks noGrp="1"/>
-          </p:cNvSpPr>
-          <p:nvPr>
-            <p:ph type="title"/>
-          </p:nvPr>
-        </p:nvSpPr>
-        <p:spPr/>
-        <p:txBody>
-          <a:bodyPr/>
-          <a:lstStyle/>
-          <a:p/>
-        </p:txBody>
-      </p:sp>
+      <p:grpSpPr>
+        <a:xfrm>
+          <a:off x="0" y="0"/>
+          <a:ext cx="0" cy="0"/>
+          <a:chOff x="0" y="0"/>
+          <a:chExt cx="0" cy="0"/>
+        </a:xfrm>
+      </p:grpSpPr>
       <p:sp>
         <p:nvSpPr>
           <p:cNvPr id="3" name="TextBox 2"/>
@@ -3651,7 +3620,7 @@
         <p:spPr>
           <a:xfrm>
             <a:off x="457200" y="1371600"/>
-            <a:ext cx="10972800" cy="5029200"/>
+            <a:ext cx="10972800" cy="3913892"/>
           </a:xfrm>
           <a:prstGeom prst="rect">
             <a:avLst/>
@@ -3671,108 +3640,88 @@
               <a:defRPr sz="1800"/>
             </a:pPr>
             <a:r>
+              <a:rPr sz="2400" dirty="0"/>
               <a:t>1. Augmentation did NOT improve AUC for any architecture</a:t>
             </a:r>
           </a:p>
           <a:p>
             <a:pPr>
-              <a:spcAft>
-                <a:spcPts val="1000"/>
-              </a:spcAft>
-              <a:defRPr sz="1800"/>
-            </a:pPr>
-            <a:r>
+              <a:defRPr sz="1800"/>
+            </a:pPr>
+            <a:r>
+              <a:rPr sz="2400" dirty="0"/>
               <a:t>     → Consistent with original paper (their AUC also dropped)</a:t>
             </a:r>
           </a:p>
           <a:p>
             <a:pPr>
-              <a:spcAft>
-                <a:spcPts val="1000"/>
-              </a:spcAft>
-              <a:defRPr sz="1800"/>
-            </a:pPr>
-          </a:p>
-          <a:p>
-            <a:pPr>
-              <a:spcAft>
-                <a:spcPts val="1000"/>
-              </a:spcAft>
-              <a:defRPr sz="1800"/>
-            </a:pPr>
-            <a:r>
-              <a:t>2. ResNet-Like remains best performer (0.94, Part 1)</a:t>
-            </a:r>
-          </a:p>
-          <a:p>
-            <a:pPr>
-              <a:spcAft>
-                <a:spcPts val="1000"/>
-              </a:spcAft>
-              <a:defRPr sz="1800"/>
-            </a:pPr>
-          </a:p>
-          <a:p>
-            <a:pPr>
-              <a:spcAft>
-                <a:spcPts val="1000"/>
-              </a:spcAft>
-              <a:defRPr sz="1800"/>
-            </a:pPr>
-            <a:r>
-              <a:t>3. Class balancing (downsampling) is harmful</a:t>
-            </a:r>
-          </a:p>
-          <a:p>
-            <a:pPr>
-              <a:spcAft>
-                <a:spcPts val="1000"/>
-              </a:spcAft>
-              <a:defRPr sz="1800"/>
-            </a:pPr>
-            <a:r>
-              <a:t>     → Confirmed from Part 1: AUC drops to ~0.5</a:t>
-            </a:r>
-          </a:p>
-          <a:p>
-            <a:pPr>
-              <a:spcAft>
-                <a:spcPts val="1000"/>
-              </a:spcAft>
-              <a:defRPr sz="1800"/>
-            </a:pPr>
-            <a:r>
-              <a:t>     → Paper never used it either</a:t>
-            </a:r>
-          </a:p>
-          <a:p>
-            <a:pPr>
-              <a:spcAft>
-                <a:spcPts val="1000"/>
-              </a:spcAft>
-              <a:defRPr sz="1800"/>
-            </a:pPr>
-          </a:p>
-          <a:p>
-            <a:pPr>
-              <a:spcAft>
-                <a:spcPts val="1000"/>
-              </a:spcAft>
-              <a:defRPr sz="1800"/>
-            </a:pPr>
-            <a:r>
-              <a:t>4. Performance ceiling ≈ 0.94 is DATASET limited</a:t>
-            </a:r>
-          </a:p>
-          <a:p>
-            <a:pPr>
-              <a:spcAft>
-                <a:spcPts val="1000"/>
-              </a:spcAft>
-              <a:defRPr sz="1800"/>
-            </a:pPr>
-            <a:r>
+              <a:defRPr sz="1800"/>
+            </a:pPr>
+            <a:endParaRPr sz="2400" dirty="0"/>
+          </a:p>
+          <a:p>
+            <a:pPr>
+              <a:defRPr sz="1800"/>
+            </a:pPr>
+            <a:r>
+              <a:rPr sz="2400" dirty="0"/>
+              <a:t>2. </a:t>
+            </a:r>
+            <a:r>
+              <a:rPr sz="2400" dirty="0" err="1"/>
+              <a:t>ResNet</a:t>
+            </a:r>
+            <a:r>
+              <a:rPr sz="2400" dirty="0"/>
+              <a:t>-Like remains best performer (0.94, Part 1)</a:t>
+            </a:r>
+          </a:p>
+          <a:p>
+            <a:pPr>
+              <a:defRPr sz="1800"/>
+            </a:pPr>
+            <a:endParaRPr sz="2400" dirty="0"/>
+          </a:p>
+          <a:p>
+            <a:pPr>
+              <a:defRPr sz="1800"/>
+            </a:pPr>
+            <a:r>
+              <a:rPr sz="2400" dirty="0"/>
+              <a:t>3. Performance ceiling ≈ 0.94 is DATASET limited</a:t>
+            </a:r>
+          </a:p>
+          <a:p>
+            <a:pPr>
+              <a:defRPr sz="1800"/>
+            </a:pPr>
+            <a:r>
+              <a:rPr sz="2400" dirty="0"/>
               <a:t>     (diversity of patients, not volume of examples)</a:t>
+            </a:r>
+          </a:p>
+          <a:p>
+            <a:pPr>
+              <a:defRPr sz="1800"/>
+            </a:pPr>
+            <a:endParaRPr sz="2400" dirty="0"/>
+          </a:p>
+          <a:p>
+            <a:pPr>
+              <a:defRPr sz="1800"/>
+            </a:pPr>
+            <a:r>
+              <a:rPr sz="2400" dirty="0"/>
+              <a:t>4. Hyperparameter tuning did not resolve the gap</a:t>
+            </a:r>
+          </a:p>
+          <a:p>
+            <a:pPr>
+              <a:defRPr sz="1800"/>
+            </a:pPr>
+            <a:r>
+              <a:rPr sz="2400" dirty="0"/>
+              <a:t>     → Confirms data diversity is the bottleneck</a:t>
             </a:r>
           </a:p>
         </p:txBody>
@@ -3786,7 +3735,7 @@
 </file>
 
 <file path=ppt/slides/slide14.xml><?xml version="1.0" encoding="utf-8"?>
-<p:sld xmlns:a="http://schemas.openxmlformats.org/drawingml/2006/main" xmlns:p="http://schemas.openxmlformats.org/presentationml/2006/main" xmlns:r="http://schemas.openxmlformats.org/officeDocument/2006/relationships">
+<p:sld xmlns:a="http://schemas.openxmlformats.org/drawingml/2006/main" xmlns:r="http://schemas.openxmlformats.org/officeDocument/2006/relationships" xmlns:p="http://schemas.openxmlformats.org/presentationml/2006/main">
   <p:cSld>
     <p:spTree>
       <p:nvGrpSpPr>
@@ -3794,24 +3743,14 @@
         <p:cNvGrpSpPr/>
         <p:nvPr/>
       </p:nvGrpSpPr>
-      <p:grpSpPr/>
-      <p:sp>
-        <p:nvSpPr>
-          <p:cNvPr id="2" name="Title 1"/>
-          <p:cNvSpPr>
-            <a:spLocks noGrp="1"/>
-          </p:cNvSpPr>
-          <p:nvPr>
-            <p:ph type="title"/>
-          </p:nvPr>
-        </p:nvSpPr>
-        <p:spPr/>
-        <p:txBody>
-          <a:bodyPr/>
-          <a:lstStyle/>
-          <a:p/>
-        </p:txBody>
-      </p:sp>
+      <p:grpSpPr>
+        <a:xfrm>
+          <a:off x="0" y="0"/>
+          <a:ext cx="0" cy="0"/>
+          <a:chOff x="0" y="0"/>
+          <a:chExt cx="0" cy="0"/>
+        </a:xfrm>
+      </p:grpSpPr>
       <p:sp>
         <p:nvSpPr>
           <p:cNvPr id="3" name="TextBox 2"/>
@@ -3856,7 +3795,7 @@
         <p:spPr>
           <a:xfrm>
             <a:off x="457200" y="1371600"/>
-            <a:ext cx="10972800" cy="5029200"/>
+            <a:ext cx="10707624" cy="4185761"/>
           </a:xfrm>
           <a:prstGeom prst="rect">
             <a:avLst/>
@@ -3864,7 +3803,7 @@
           <a:noFill/>
         </p:spPr>
         <p:txBody>
-          <a:bodyPr wrap="square">
+          <a:bodyPr wrap="square" numCol="2">
             <a:spAutoFit/>
           </a:bodyPr>
           <a:lstStyle/>
@@ -3876,6 +3815,7 @@
               <a:defRPr sz="1800"/>
             </a:pPr>
             <a:r>
+              <a:rPr sz="2400" dirty="0"/>
               <a:t>• Data diversity ≠ data volume</a:t>
             </a:r>
           </a:p>
@@ -3887,6 +3827,7 @@
               <a:defRPr sz="1800"/>
             </a:pPr>
             <a:r>
+              <a:rPr sz="2400" dirty="0"/>
               <a:t>     Only 624 unique anatomies; augmentation can't create new ones</a:t>
             </a:r>
           </a:p>
@@ -3897,15 +3838,8 @@
               </a:spcAft>
               <a:defRPr sz="1800"/>
             </a:pPr>
-          </a:p>
-          <a:p>
-            <a:pPr>
-              <a:spcAft>
-                <a:spcPts val="1000"/>
-              </a:spcAft>
-              <a:defRPr sz="1800"/>
-            </a:pPr>
-            <a:r>
+            <a:r>
+              <a:rPr sz="2400" dirty="0"/>
               <a:t>• Small normal class (263 patients)</a:t>
             </a:r>
           </a:p>
@@ -3917,6 +3851,7 @@
               <a:defRPr sz="1800"/>
             </a:pPr>
             <a:r>
+              <a:rPr sz="2400" dirty="0"/>
               <a:t>     Even 6× still only ~1,578 from same 263 anatomies</a:t>
             </a:r>
           </a:p>
@@ -3927,15 +3862,8 @@
               </a:spcAft>
               <a:defRPr sz="1800"/>
             </a:pPr>
-          </a:p>
-          <a:p>
-            <a:pPr>
-              <a:spcAft>
-                <a:spcPts val="1000"/>
-              </a:spcAft>
-              <a:defRPr sz="1800"/>
-            </a:pPr>
-            <a:r>
+            <a:r>
+              <a:rPr sz="2400" dirty="0"/>
               <a:t>• Augmentation ≠ new patients</a:t>
             </a:r>
           </a:p>
@@ -3947,6 +3875,7 @@
               <a:defRPr sz="1800"/>
             </a:pPr>
             <a:r>
+              <a:rPr sz="2400" dirty="0"/>
               <a:t>     Can't introduce new structural configurations of ONH</a:t>
             </a:r>
           </a:p>
@@ -3957,15 +3886,8 @@
               </a:spcAft>
               <a:defRPr sz="1800"/>
             </a:pPr>
-          </a:p>
-          <a:p>
-            <a:pPr>
-              <a:spcAft>
-                <a:spcPts val="1000"/>
-              </a:spcAft>
-              <a:defRPr sz="1800"/>
-            </a:pPr>
-            <a:r>
+            <a:r>
+              <a:rPr sz="2400" dirty="0"/>
               <a:t>• Training dynamics diluted</a:t>
             </a:r>
           </a:p>
@@ -3977,6 +3899,7 @@
               <a:defRPr sz="1800"/>
             </a:pPr>
             <a:r>
+              <a:rPr sz="2400" dirty="0"/>
               <a:t>     6× larger epoch → fewer unique gradients per step</a:t>
             </a:r>
           </a:p>
@@ -3987,15 +3910,8 @@
               </a:spcAft>
               <a:defRPr sz="1800"/>
             </a:pPr>
-          </a:p>
-          <a:p>
-            <a:pPr>
-              <a:spcAft>
-                <a:spcPts val="1000"/>
-              </a:spcAft>
-              <a:defRPr sz="1800"/>
-            </a:pPr>
-            <a:r>
+            <a:r>
+              <a:rPr sz="2400" dirty="0"/>
               <a:t>• Original paper found the same result</a:t>
             </a:r>
           </a:p>
@@ -4007,6 +3923,7 @@
               <a:defRPr sz="1800"/>
             </a:pPr>
             <a:r>
+              <a:rPr sz="2400" dirty="0"/>
               <a:t>     Their augmentation also reduced AUC (0.94 → 0.92)</a:t>
             </a:r>
           </a:p>
@@ -4021,7 +3938,7 @@
 </file>
 
 <file path=ppt/slides/slide15.xml><?xml version="1.0" encoding="utf-8"?>
-<p:sld xmlns:a="http://schemas.openxmlformats.org/drawingml/2006/main" xmlns:p="http://schemas.openxmlformats.org/presentationml/2006/main" xmlns:r="http://schemas.openxmlformats.org/officeDocument/2006/relationships">
+<p:sld xmlns:a="http://schemas.openxmlformats.org/drawingml/2006/main" xmlns:r="http://schemas.openxmlformats.org/officeDocument/2006/relationships" xmlns:p="http://schemas.openxmlformats.org/presentationml/2006/main">
   <p:cSld>
     <p:spTree>
       <p:nvGrpSpPr>
@@ -4029,240 +3946,14 @@
         <p:cNvGrpSpPr/>
         <p:nvPr/>
       </p:nvGrpSpPr>
-      <p:grpSpPr/>
-      <p:sp>
-        <p:nvSpPr>
-          <p:cNvPr id="2" name="Title 1"/>
-          <p:cNvSpPr>
-            <a:spLocks noGrp="1"/>
-          </p:cNvSpPr>
-          <p:nvPr>
-            <p:ph type="title"/>
-          </p:nvPr>
-        </p:nvSpPr>
-        <p:spPr/>
-        <p:txBody>
-          <a:bodyPr/>
-          <a:lstStyle/>
-          <a:p/>
-        </p:txBody>
-      </p:sp>
-      <p:sp>
-        <p:nvSpPr>
-          <p:cNvPr id="3" name="TextBox 2"/>
-          <p:cNvSpPr txBox="1"/>
-          <p:nvPr/>
-        </p:nvSpPr>
-        <p:spPr>
-          <a:xfrm>
-            <a:off x="457200" y="274320"/>
-            <a:ext cx="10972800" cy="914400"/>
-          </a:xfrm>
-          <a:prstGeom prst="rect">
-            <a:avLst/>
-          </a:prstGeom>
-          <a:noFill/>
-        </p:spPr>
-        <p:txBody>
-          <a:bodyPr wrap="square">
-            <a:spAutoFit/>
-          </a:bodyPr>
-          <a:lstStyle/>
-          <a:p>
-            <a:pPr>
-              <a:defRPr sz="3200" b="1">
-                <a:solidFill>
-                  <a:srgbClr val="2C3E50"/>
-                </a:solidFill>
-              </a:defRPr>
-            </a:pPr>
-            <a:r>
-              <a:t>Lesson from Part 1: No Class Balancing</a:t>
-            </a:r>
-          </a:p>
-        </p:txBody>
-      </p:sp>
-      <p:sp>
-        <p:nvSpPr>
-          <p:cNvPr id="4" name="TextBox 3"/>
-          <p:cNvSpPr txBox="1"/>
-          <p:nvPr/>
-        </p:nvSpPr>
-        <p:spPr>
-          <a:xfrm>
-            <a:off x="457200" y="1371600"/>
-            <a:ext cx="10972800" cy="5029200"/>
-          </a:xfrm>
-          <a:prstGeom prst="rect">
-            <a:avLst/>
-          </a:prstGeom>
-          <a:noFill/>
-        </p:spPr>
-        <p:txBody>
-          <a:bodyPr wrap="square">
-            <a:spAutoFit/>
-          </a:bodyPr>
-          <a:lstStyle/>
-          <a:p>
-            <a:pPr>
-              <a:spcAft>
-                <a:spcPts val="1000"/>
-              </a:spcAft>
-              <a:defRPr sz="1800"/>
-            </a:pPr>
-            <a:r>
-              <a:t>• Part 1 tested downsampling majority class (Glaucoma)</a:t>
-            </a:r>
-          </a:p>
-          <a:p>
-            <a:pPr>
-              <a:spcAft>
-                <a:spcPts val="1000"/>
-              </a:spcAft>
-              <a:defRPr sz="1800"/>
-            </a:pPr>
-            <a:r>
-              <a:t>     to match minority (Normal): 888 → 406 training volumes</a:t>
-            </a:r>
-          </a:p>
-          <a:p>
-            <a:pPr>
-              <a:spcAft>
-                <a:spcPts val="1000"/>
-              </a:spcAft>
-              <a:defRPr sz="1800"/>
-            </a:pPr>
-          </a:p>
-          <a:p>
-            <a:pPr>
-              <a:spcAft>
-                <a:spcPts val="1000"/>
-              </a:spcAft>
-              <a:defRPr sz="1800"/>
-            </a:pPr>
-            <a:r>
-              <a:t>• Result: CATASTROPHIC</a:t>
-            </a:r>
-          </a:p>
-          <a:p>
-            <a:pPr>
-              <a:spcAft>
-                <a:spcPts val="1000"/>
-              </a:spcAft>
-              <a:defRPr sz="1800"/>
-            </a:pPr>
-            <a:r>
-              <a:t>     ResNet-Like: 0.94 → ~0.5 (random chance)</a:t>
-            </a:r>
-          </a:p>
-          <a:p>
-            <a:pPr>
-              <a:spcAft>
-                <a:spcPts val="1000"/>
-              </a:spcAft>
-              <a:defRPr sz="1800"/>
-            </a:pPr>
-            <a:r>
-              <a:t>     Attention:   0.93 → ~0.5 (random chance)</a:t>
-            </a:r>
-          </a:p>
-          <a:p>
-            <a:pPr>
-              <a:spcAft>
-                <a:spcPts val="1000"/>
-              </a:spcAft>
-              <a:defRPr sz="1800"/>
-            </a:pPr>
-          </a:p>
-          <a:p>
-            <a:pPr>
-              <a:spcAft>
-                <a:spcPts val="1000"/>
-              </a:spcAft>
-              <a:defRPr sz="1800"/>
-            </a:pPr>
-            <a:r>
-              <a:t>• Why: Glaucoma is heterogeneous (many patterns)</a:t>
-            </a:r>
-          </a:p>
-          <a:p>
-            <a:pPr>
-              <a:spcAft>
-                <a:spcPts val="1000"/>
-              </a:spcAft>
-              <a:defRPr sz="1800"/>
-            </a:pPr>
-            <a:r>
-              <a:t>     needs many examples; Normal is homogeneous</a:t>
-            </a:r>
-          </a:p>
-          <a:p>
-            <a:pPr>
-              <a:spcAft>
-                <a:spcPts val="1000"/>
-              </a:spcAft>
-              <a:defRPr sz="1800"/>
-            </a:pPr>
-          </a:p>
-          <a:p>
-            <a:pPr>
-              <a:spcAft>
-                <a:spcPts val="1000"/>
-              </a:spcAft>
-              <a:defRPr sz="1800"/>
-            </a:pPr>
-            <a:r>
-              <a:t>• Paper never used class balancing</a:t>
-            </a:r>
-          </a:p>
-          <a:p>
-            <a:pPr>
-              <a:spcAft>
-                <a:spcPts val="1000"/>
-              </a:spcAft>
-              <a:defRPr sz="1800"/>
-            </a:pPr>
-            <a:r>
-              <a:t>• Part 2 keeps unbalanced distribution as-is</a:t>
-            </a:r>
-          </a:p>
-        </p:txBody>
-      </p:sp>
-    </p:spTree>
-  </p:cSld>
-  <p:clrMapOvr>
-    <a:masterClrMapping/>
-  </p:clrMapOvr>
-</p:sld>
-</file>
-
-<file path=ppt/slides/slide16.xml><?xml version="1.0" encoding="utf-8"?>
-<p:sld xmlns:a="http://schemas.openxmlformats.org/drawingml/2006/main" xmlns:p="http://schemas.openxmlformats.org/presentationml/2006/main" xmlns:r="http://schemas.openxmlformats.org/officeDocument/2006/relationships">
-  <p:cSld>
-    <p:spTree>
-      <p:nvGrpSpPr>
-        <p:cNvPr id="1" name=""/>
-        <p:cNvGrpSpPr/>
-        <p:nvPr/>
-      </p:nvGrpSpPr>
-      <p:grpSpPr/>
-      <p:sp>
-        <p:nvSpPr>
-          <p:cNvPr id="2" name="Title 1"/>
-          <p:cNvSpPr>
-            <a:spLocks noGrp="1"/>
-          </p:cNvSpPr>
-          <p:nvPr>
-            <p:ph type="title"/>
-          </p:nvPr>
-        </p:nvSpPr>
-        <p:spPr/>
-        <p:txBody>
-          <a:bodyPr/>
-          <a:lstStyle/>
-          <a:p/>
-        </p:txBody>
-      </p:sp>
+      <p:grpSpPr>
+        <a:xfrm>
+          <a:off x="0" y="0"/>
+          <a:ext cx="0" cy="0"/>
+          <a:chOff x="0" y="0"/>
+          <a:chExt cx="0" cy="0"/>
+        </a:xfrm>
+      </p:grpSpPr>
       <p:sp>
         <p:nvSpPr>
           <p:cNvPr id="3" name="TextBox 2"/>
@@ -4314,8 +4005,8 @@
         </p:blipFill>
         <p:spPr>
           <a:xfrm>
-            <a:off x="1371600" y="1371600"/>
-            <a:ext cx="9144000" cy="5455612"/>
+            <a:off x="1371600" y="1188720"/>
+            <a:ext cx="9144000" cy="5212080"/>
           </a:xfrm>
           <a:prstGeom prst="rect">
             <a:avLst/>
@@ -4330,8 +4021,8 @@
 </p:sld>
 </file>
 
-<file path=ppt/slides/slide17.xml><?xml version="1.0" encoding="utf-8"?>
-<p:sld xmlns:a="http://schemas.openxmlformats.org/drawingml/2006/main" xmlns:p="http://schemas.openxmlformats.org/presentationml/2006/main" xmlns:r="http://schemas.openxmlformats.org/officeDocument/2006/relationships">
+<file path=ppt/slides/slide16.xml><?xml version="1.0" encoding="utf-8"?>
+<p:sld xmlns:a="http://schemas.openxmlformats.org/drawingml/2006/main" xmlns:r="http://schemas.openxmlformats.org/officeDocument/2006/relationships" xmlns:p="http://schemas.openxmlformats.org/presentationml/2006/main">
   <p:cSld>
     <p:spTree>
       <p:nvGrpSpPr>
@@ -4339,24 +4030,14 @@
         <p:cNvGrpSpPr/>
         <p:nvPr/>
       </p:nvGrpSpPr>
-      <p:grpSpPr/>
-      <p:sp>
-        <p:nvSpPr>
-          <p:cNvPr id="2" name="Title 1"/>
-          <p:cNvSpPr>
-            <a:spLocks noGrp="1"/>
-          </p:cNvSpPr>
-          <p:nvPr>
-            <p:ph type="title"/>
-          </p:nvPr>
-        </p:nvSpPr>
-        <p:spPr/>
-        <p:txBody>
-          <a:bodyPr/>
-          <a:lstStyle/>
-          <a:p/>
-        </p:txBody>
-      </p:sp>
+      <p:grpSpPr>
+        <a:xfrm>
+          <a:off x="0" y="0"/>
+          <a:ext cx="0" cy="0"/>
+          <a:chOff x="0" y="0"/>
+          <a:chExt cx="0" cy="0"/>
+        </a:xfrm>
+      </p:grpSpPr>
       <p:sp>
         <p:nvSpPr>
           <p:cNvPr id="3" name="TextBox 2"/>
@@ -4401,7 +4082,7 @@
         <p:spPr>
           <a:xfrm>
             <a:off x="457200" y="1371600"/>
-            <a:ext cx="10972800" cy="5029200"/>
+            <a:ext cx="10972800" cy="3447098"/>
           </a:xfrm>
           <a:prstGeom prst="rect">
             <a:avLst/>
@@ -4421,6 +4102,7 @@
               <a:defRPr sz="1800"/>
             </a:pPr>
             <a:r>
+              <a:rPr sz="2400" dirty="0"/>
               <a:t>• 5-Fold Cross-Validation for confidence intervals</a:t>
             </a:r>
           </a:p>
@@ -4432,6 +4114,7 @@
               <a:defRPr sz="1800"/>
             </a:pPr>
             <a:r>
+              <a:rPr sz="2400" dirty="0"/>
               <a:t>• Multi-center data from additional institutions/scanners</a:t>
             </a:r>
           </a:p>
@@ -4443,6 +4126,7 @@
               <a:defRPr sz="1800"/>
             </a:pPr>
             <a:r>
+              <a:rPr sz="2400" dirty="0"/>
               <a:t>• Transfer learning / medical imaging foundation models</a:t>
             </a:r>
           </a:p>
@@ -4454,6 +4138,7 @@
               <a:defRPr sz="1800"/>
             </a:pPr>
             <a:r>
+              <a:rPr sz="2400" dirty="0"/>
               <a:t>• Contrastive self-supervised pretraining</a:t>
             </a:r>
           </a:p>
@@ -4465,6 +4150,7 @@
               <a:defRPr sz="1800"/>
             </a:pPr>
             <a:r>
+              <a:rPr sz="2400" dirty="0"/>
               <a:t>• Grad-CAM explainability for clinical trust</a:t>
             </a:r>
           </a:p>
@@ -4476,6 +4162,7 @@
               <a:defRPr sz="1800"/>
             </a:pPr>
             <a:r>
+              <a:rPr sz="2400" dirty="0"/>
               <a:t>• Ensemble methods across architectures</a:t>
             </a:r>
           </a:p>
@@ -4487,7 +4174,24 @@
               <a:defRPr sz="1800"/>
             </a:pPr>
             <a:r>
-              <a:t>• Web application deployment (Gradio/HuggingFace)</a:t>
+              <a:rPr sz="2400" dirty="0"/>
+              <a:t>• Web application deployment (</a:t>
+            </a:r>
+            <a:r>
+              <a:rPr sz="2400" dirty="0" err="1"/>
+              <a:t>Gradio</a:t>
+            </a:r>
+            <a:r>
+              <a:rPr sz="2400" dirty="0"/>
+              <a:t>/</a:t>
+            </a:r>
+            <a:r>
+              <a:rPr sz="2400" dirty="0" err="1"/>
+              <a:t>HuggingFace</a:t>
+            </a:r>
+            <a:r>
+              <a:rPr sz="2400" dirty="0"/>
+              <a:t>)</a:t>
             </a:r>
           </a:p>
         </p:txBody>
@@ -4500,8 +4204,8 @@
 </p:sld>
 </file>
 
-<file path=ppt/slides/slide18.xml><?xml version="1.0" encoding="utf-8"?>
-<p:sld xmlns:a="http://schemas.openxmlformats.org/drawingml/2006/main" xmlns:p="http://schemas.openxmlformats.org/presentationml/2006/main" xmlns:r="http://schemas.openxmlformats.org/officeDocument/2006/relationships">
+<file path=ppt/slides/slide17.xml><?xml version="1.0" encoding="utf-8"?>
+<p:sld xmlns:a="http://schemas.openxmlformats.org/drawingml/2006/main" xmlns:r="http://schemas.openxmlformats.org/officeDocument/2006/relationships" xmlns:p="http://schemas.openxmlformats.org/presentationml/2006/main">
   <p:cSld>
     <p:spTree>
       <p:nvGrpSpPr>
@@ -4509,24 +4213,14 @@
         <p:cNvGrpSpPr/>
         <p:nvPr/>
       </p:nvGrpSpPr>
-      <p:grpSpPr/>
-      <p:sp>
-        <p:nvSpPr>
-          <p:cNvPr id="2" name="Title 1"/>
-          <p:cNvSpPr>
-            <a:spLocks noGrp="1"/>
-          </p:cNvSpPr>
-          <p:nvPr>
-            <p:ph type="title"/>
-          </p:nvPr>
-        </p:nvSpPr>
-        <p:spPr/>
-        <p:txBody>
-          <a:bodyPr/>
-          <a:lstStyle/>
-          <a:p/>
-        </p:txBody>
-      </p:sp>
+      <p:grpSpPr>
+        <a:xfrm>
+          <a:off x="0" y="0"/>
+          <a:ext cx="0" cy="0"/>
+          <a:chOff x="0" y="0"/>
+          <a:chExt cx="0" cy="0"/>
+        </a:xfrm>
+      </p:grpSpPr>
       <p:sp>
         <p:nvSpPr>
           <p:cNvPr id="3" name="TextBox 2"/>
@@ -4591,6 +4285,7 @@
               <a:defRPr sz="1800"/>
             </a:pPr>
             <a:r>
+              <a:rPr dirty="0"/>
               <a:t>PART_2/</a:t>
             </a:r>
           </a:p>
@@ -4602,39 +4297,67 @@
               <a:defRPr sz="1800"/>
             </a:pPr>
             <a:r>
-              <a:t>  ├─ DW-EDA.ipynb            Data wrangling &amp; EDA</a:t>
-            </a:r>
-          </a:p>
-          <a:p>
-            <a:pPr>
-              <a:spcAft>
-                <a:spcPts val="1000"/>
-              </a:spcAft>
-              <a:defRPr sz="1800"/>
-            </a:pPr>
-            <a:r>
-              <a:t>  ├─ PPs-Modeling.ipynb      Preprocessing + Modeling</a:t>
-            </a:r>
-          </a:p>
-          <a:p>
-            <a:pPr>
-              <a:spcAft>
-                <a:spcPts val="1000"/>
-              </a:spcAft>
-              <a:defRPr sz="1800"/>
-            </a:pPr>
-            <a:r>
-              <a:t>  ├─ model_metrics.json      Model metrics file</a:t>
-            </a:r>
-          </a:p>
-          <a:p>
-            <a:pPr>
-              <a:spcAft>
-                <a:spcPts val="1000"/>
-              </a:spcAft>
-              <a:defRPr sz="1800"/>
-            </a:pPr>
-            <a:r>
+              <a:rPr dirty="0"/>
+              <a:t>  ├─ DW-</a:t>
+            </a:r>
+            <a:r>
+              <a:rPr dirty="0" err="1"/>
+              <a:t>EDA.ipynb</a:t>
+            </a:r>
+            <a:r>
+              <a:rPr dirty="0"/>
+              <a:t>            Data wrangling &amp; EDA</a:t>
+            </a:r>
+          </a:p>
+          <a:p>
+            <a:pPr>
+              <a:spcAft>
+                <a:spcPts val="1000"/>
+              </a:spcAft>
+              <a:defRPr sz="1800"/>
+            </a:pPr>
+            <a:r>
+              <a:rPr dirty="0"/>
+              <a:t>  ├─ PPs-</a:t>
+            </a:r>
+            <a:r>
+              <a:rPr dirty="0" err="1"/>
+              <a:t>Modeling.ipynb</a:t>
+            </a:r>
+            <a:r>
+              <a:rPr dirty="0"/>
+              <a:t>      Preprocessing + Modeling</a:t>
+            </a:r>
+          </a:p>
+          <a:p>
+            <a:pPr>
+              <a:spcAft>
+                <a:spcPts val="1000"/>
+              </a:spcAft>
+              <a:defRPr sz="1800"/>
+            </a:pPr>
+            <a:r>
+              <a:rPr dirty="0"/>
+              <a:t>  ├─ </a:t>
+            </a:r>
+            <a:r>
+              <a:rPr dirty="0" err="1"/>
+              <a:t>model_metrics.json</a:t>
+            </a:r>
+            <a:r>
+              <a:rPr dirty="0"/>
+              <a:t>      Model metrics file</a:t>
+            </a:r>
+          </a:p>
+          <a:p>
+            <a:pPr>
+              <a:spcAft>
+                <a:spcPts val="1000"/>
+              </a:spcAft>
+              <a:defRPr sz="1800"/>
+            </a:pPr>
+            <a:r>
+              <a:rPr dirty="0"/>
               <a:t>  ├─ Final Report (.md)</a:t>
             </a:r>
           </a:p>
@@ -4646,6 +4369,7 @@
               <a:defRPr sz="1800"/>
             </a:pPr>
             <a:r>
+              <a:rPr dirty="0"/>
               <a:t>  └─ Presentation (.pptx)</a:t>
             </a:r>
           </a:p>
@@ -4656,26 +4380,41 @@
               </a:spcAft>
               <a:defRPr sz="1800"/>
             </a:pPr>
-          </a:p>
-          <a:p>
-            <a:pPr>
-              <a:spcAft>
-                <a:spcPts val="1000"/>
-              </a:spcAft>
-              <a:defRPr sz="1800"/>
-            </a:pPr>
-            <a:r>
-              <a:t>octcv/mdl_lib/</a:t>
-            </a:r>
-          </a:p>
-          <a:p>
-            <a:pPr>
-              <a:spcAft>
-                <a:spcPts val="1000"/>
-              </a:spcAft>
-              <a:defRPr sz="1800"/>
-            </a:pPr>
-            <a:r>
+            <a:endParaRPr dirty="0"/>
+          </a:p>
+          <a:p>
+            <a:pPr>
+              <a:spcAft>
+                <a:spcPts val="1000"/>
+              </a:spcAft>
+              <a:defRPr sz="1800"/>
+            </a:pPr>
+            <a:r>
+              <a:rPr dirty="0" err="1"/>
+              <a:t>octcv</a:t>
+            </a:r>
+            <a:r>
+              <a:rPr dirty="0"/>
+              <a:t>/</a:t>
+            </a:r>
+            <a:r>
+              <a:rPr dirty="0" err="1"/>
+              <a:t>mdl_lib</a:t>
+            </a:r>
+            <a:r>
+              <a:rPr dirty="0"/>
+              <a:t>/</a:t>
+            </a:r>
+          </a:p>
+          <a:p>
+            <a:pPr>
+              <a:spcAft>
+                <a:spcPts val="1000"/>
+              </a:spcAft>
+              <a:defRPr sz="1800"/>
+            </a:pPr>
+            <a:r>
+              <a:rPr dirty="0"/>
               <a:t>  ├─ architectures.py        3 CNN architectures</a:t>
             </a:r>
           </a:p>
@@ -4687,19 +4426,55 @@
               <a:defRPr sz="1800"/>
             </a:pPr>
             <a:r>
-              <a:t>  ├─ __init__.py             XVolSet, train_model(), ModelEvaluator</a:t>
-            </a:r>
-          </a:p>
-          <a:p>
-            <a:pPr>
-              <a:spcAft>
-                <a:spcPts val="1000"/>
-              </a:spcAft>
-              <a:defRPr sz="1800"/>
-            </a:pPr>
-            <a:r>
-              <a:t>  └─ callbacks.py            LivePlot, EpochProgressBar</a:t>
-            </a:r>
+              <a:rPr dirty="0"/>
+              <a:t>  ├─ __init__.py             </a:t>
+            </a:r>
+            <a:r>
+              <a:rPr dirty="0" err="1"/>
+              <a:t>XVolSet</a:t>
+            </a:r>
+            <a:r>
+              <a:rPr dirty="0"/>
+              <a:t>, </a:t>
+            </a:r>
+            <a:r>
+              <a:rPr dirty="0" err="1"/>
+              <a:t>train_model</a:t>
+            </a:r>
+            <a:r>
+              <a:rPr dirty="0"/>
+              <a:t>(), </a:t>
+            </a:r>
+            <a:r>
+              <a:rPr dirty="0" err="1"/>
+              <a:t>ModelEvaluator</a:t>
+            </a:r>
+            <a:endParaRPr dirty="0"/>
+          </a:p>
+          <a:p>
+            <a:pPr>
+              <a:spcAft>
+                <a:spcPts val="1000"/>
+              </a:spcAft>
+              <a:defRPr sz="1800"/>
+            </a:pPr>
+            <a:r>
+              <a:rPr dirty="0"/>
+              <a:t>  └─ callbacks.py            </a:t>
+            </a:r>
+            <a:r>
+              <a:rPr dirty="0" err="1"/>
+              <a:t>LivePlot</a:t>
+            </a:r>
+            <a:r>
+              <a:rPr dirty="0"/>
+              <a:t>, </a:t>
+            </a:r>
+            <a:r>
+              <a:rPr dirty="0" err="1"/>
+              <a:t>EpochProgressBar</a:t>
+            </a:r>
+            <a:endParaRPr dirty="0"/>
           </a:p>
         </p:txBody>
       </p:sp>
@@ -4711,8 +4486,8 @@
 </p:sld>
 </file>
 
-<file path=ppt/slides/slide19.xml><?xml version="1.0" encoding="utf-8"?>
-<p:sld xmlns:a="http://schemas.openxmlformats.org/drawingml/2006/main" xmlns:p="http://schemas.openxmlformats.org/presentationml/2006/main" xmlns:r="http://schemas.openxmlformats.org/officeDocument/2006/relationships">
+<file path=ppt/slides/slide18.xml><?xml version="1.0" encoding="utf-8"?>
+<p:sld xmlns:a="http://schemas.openxmlformats.org/drawingml/2006/main" xmlns:r="http://schemas.openxmlformats.org/officeDocument/2006/relationships" xmlns:p="http://schemas.openxmlformats.org/presentationml/2006/main">
   <p:cSld>
     <p:spTree>
       <p:nvGrpSpPr>
@@ -4720,24 +4495,14 @@
         <p:cNvGrpSpPr/>
         <p:nvPr/>
       </p:nvGrpSpPr>
-      <p:grpSpPr/>
-      <p:sp>
-        <p:nvSpPr>
-          <p:cNvPr id="2" name="Title 1"/>
-          <p:cNvSpPr>
-            <a:spLocks noGrp="1"/>
-          </p:cNvSpPr>
-          <p:nvPr>
-            <p:ph type="title"/>
-          </p:nvPr>
-        </p:nvSpPr>
-        <p:spPr/>
-        <p:txBody>
-          <a:bodyPr/>
-          <a:lstStyle/>
-          <a:p/>
-        </p:txBody>
-      </p:sp>
+      <p:grpSpPr>
+        <a:xfrm>
+          <a:off x="0" y="0"/>
+          <a:ext cx="0" cy="0"/>
+          <a:chOff x="0" y="0"/>
+          <a:chExt cx="0" cy="0"/>
+        </a:xfrm>
+      </p:grpSpPr>
       <p:sp>
         <p:nvSpPr>
           <p:cNvPr id="3" name="TextBox 2"/>
@@ -4859,8 +4624,8 @@
 </p:sld>
 </file>
 
-<file path=ppt/slides/slide2.xml><?xml version="1.0" encoding="utf-8"?>
-<p:sld xmlns:a="http://schemas.openxmlformats.org/drawingml/2006/main" xmlns:p="http://schemas.openxmlformats.org/presentationml/2006/main" xmlns:r="http://schemas.openxmlformats.org/officeDocument/2006/relationships">
+<file path=ppt/slides/slide19.xml><?xml version="1.0" encoding="utf-8"?>
+<p:sld xmlns:a="http://schemas.openxmlformats.org/drawingml/2006/main" xmlns:r="http://schemas.openxmlformats.org/officeDocument/2006/relationships" xmlns:p="http://schemas.openxmlformats.org/presentationml/2006/main">
   <p:cSld>
     <p:spTree>
       <p:nvGrpSpPr>
@@ -4868,24 +4633,89 @@
         <p:cNvGrpSpPr/>
         <p:nvPr/>
       </p:nvGrpSpPr>
-      <p:grpSpPr/>
-      <p:sp>
-        <p:nvSpPr>
-          <p:cNvPr id="2" name="Title 1"/>
-          <p:cNvSpPr>
-            <a:spLocks noGrp="1"/>
-          </p:cNvSpPr>
-          <p:nvPr>
-            <p:ph type="title"/>
-          </p:nvPr>
-        </p:nvSpPr>
-        <p:spPr/>
-        <p:txBody>
-          <a:bodyPr/>
-          <a:lstStyle/>
-          <a:p/>
-        </p:txBody>
-      </p:sp>
+      <p:grpSpPr>
+        <a:xfrm>
+          <a:off x="0" y="0"/>
+          <a:ext cx="0" cy="0"/>
+          <a:chOff x="0" y="0"/>
+          <a:chExt cx="0" cy="0"/>
+        </a:xfrm>
+      </p:grpSpPr>
+      <p:sp>
+        <p:nvSpPr>
+          <p:cNvPr id="3" name="TextBox 2"/>
+          <p:cNvSpPr txBox="1"/>
+          <p:nvPr/>
+        </p:nvSpPr>
+        <p:spPr>
+          <a:xfrm>
+            <a:off x="1828800" y="2743200"/>
+            <a:ext cx="8229600" cy="1828800"/>
+          </a:xfrm>
+          <a:prstGeom prst="rect">
+            <a:avLst/>
+          </a:prstGeom>
+          <a:noFill/>
+        </p:spPr>
+        <p:txBody>
+          <a:bodyPr wrap="square">
+            <a:spAutoFit/>
+          </a:bodyPr>
+          <a:lstStyle/>
+          <a:p>
+            <a:pPr algn="ctr">
+              <a:defRPr sz="4400" b="1">
+                <a:solidFill>
+                  <a:srgbClr val="2C3E50"/>
+                </a:solidFill>
+              </a:defRPr>
+            </a:pPr>
+            <a:r>
+              <a:t>Thank You</a:t>
+            </a:r>
+          </a:p>
+          <a:p>
+            <a:endParaRPr/>
+          </a:p>
+          <a:p>
+            <a:pPr algn="ctr">
+              <a:defRPr sz="2800">
+                <a:solidFill>
+                  <a:srgbClr val="7F8C8D"/>
+                </a:solidFill>
+              </a:defRPr>
+            </a:pPr>
+            <a:r>
+              <a:t>Questions?</a:t>
+            </a:r>
+          </a:p>
+        </p:txBody>
+      </p:sp>
+    </p:spTree>
+  </p:cSld>
+  <p:clrMapOvr>
+    <a:masterClrMapping/>
+  </p:clrMapOvr>
+</p:sld>
+</file>
+
+<file path=ppt/slides/slide2.xml><?xml version="1.0" encoding="utf-8"?>
+<p:sld xmlns:a="http://schemas.openxmlformats.org/drawingml/2006/main" xmlns:r="http://schemas.openxmlformats.org/officeDocument/2006/relationships" xmlns:p="http://schemas.openxmlformats.org/presentationml/2006/main">
+  <p:cSld>
+    <p:spTree>
+      <p:nvGrpSpPr>
+        <p:cNvPr id="1" name=""/>
+        <p:cNvGrpSpPr/>
+        <p:nvPr/>
+      </p:nvGrpSpPr>
+      <p:grpSpPr>
+        <a:xfrm>
+          <a:off x="0" y="0"/>
+          <a:ext cx="0" cy="0"/>
+          <a:chOff x="0" y="0"/>
+          <a:chExt cx="0" cy="0"/>
+        </a:xfrm>
+      </p:grpSpPr>
       <p:sp>
         <p:nvSpPr>
           <p:cNvPr id="3" name="TextBox 2"/>
@@ -4930,7 +4760,7 @@
         <p:spPr>
           <a:xfrm>
             <a:off x="457200" y="1371600"/>
-            <a:ext cx="10972800" cy="5029200"/>
+            <a:ext cx="10972800" cy="3016210"/>
           </a:xfrm>
           <a:prstGeom prst="rect">
             <a:avLst/>
@@ -4950,6 +4780,7 @@
               <a:defRPr sz="1800"/>
             </a:pPr>
             <a:r>
+              <a:rPr sz="2000" dirty="0"/>
               <a:t>1. Project Overview &amp; Motivation</a:t>
             </a:r>
           </a:p>
@@ -4961,6 +4792,7 @@
               <a:defRPr sz="1800"/>
             </a:pPr>
             <a:r>
+              <a:rPr sz="2000" dirty="0"/>
               <a:t>2. Data &amp; EDA Findings</a:t>
             </a:r>
           </a:p>
@@ -4972,6 +4804,7 @@
               <a:defRPr sz="1800"/>
             </a:pPr>
             <a:r>
+              <a:rPr sz="2000" dirty="0"/>
               <a:t>3. Augmentation Pipeline Design</a:t>
             </a:r>
           </a:p>
@@ -4983,6 +4816,7 @@
               <a:defRPr sz="1800"/>
             </a:pPr>
             <a:r>
+              <a:rPr sz="2000" dirty="0"/>
               <a:t>4. Model Training &amp; Results</a:t>
             </a:r>
           </a:p>
@@ -4994,6 +4828,7 @@
               <a:defRPr sz="1800"/>
             </a:pPr>
             <a:r>
+              <a:rPr sz="2000" dirty="0"/>
               <a:t>5. Part 1 vs Part 2 Comparison</a:t>
             </a:r>
           </a:p>
@@ -5005,6 +4840,7 @@
               <a:defRPr sz="1800"/>
             </a:pPr>
             <a:r>
+              <a:rPr sz="2000" dirty="0"/>
               <a:t>6. Key Findings &amp; Conclusions</a:t>
             </a:r>
           </a:p>
@@ -5016,90 +4852,8 @@
               <a:defRPr sz="1800"/>
             </a:pPr>
             <a:r>
+              <a:rPr sz="2000" dirty="0"/>
               <a:t>7. Future Directions</a:t>
-            </a:r>
-          </a:p>
-        </p:txBody>
-      </p:sp>
-    </p:spTree>
-  </p:cSld>
-  <p:clrMapOvr>
-    <a:masterClrMapping/>
-  </p:clrMapOvr>
-</p:sld>
-</file>
-
-<file path=ppt/slides/slide20.xml><?xml version="1.0" encoding="utf-8"?>
-<p:sld xmlns:a="http://schemas.openxmlformats.org/drawingml/2006/main" xmlns:p="http://schemas.openxmlformats.org/presentationml/2006/main" xmlns:r="http://schemas.openxmlformats.org/officeDocument/2006/relationships">
-  <p:cSld>
-    <p:spTree>
-      <p:nvGrpSpPr>
-        <p:cNvPr id="1" name=""/>
-        <p:cNvGrpSpPr/>
-        <p:nvPr/>
-      </p:nvGrpSpPr>
-      <p:grpSpPr/>
-      <p:sp>
-        <p:nvSpPr>
-          <p:cNvPr id="2" name="Title 1"/>
-          <p:cNvSpPr>
-            <a:spLocks noGrp="1"/>
-          </p:cNvSpPr>
-          <p:nvPr>
-            <p:ph type="title"/>
-          </p:nvPr>
-        </p:nvSpPr>
-        <p:spPr/>
-        <p:txBody>
-          <a:bodyPr/>
-          <a:lstStyle/>
-          <a:p/>
-        </p:txBody>
-      </p:sp>
-      <p:sp>
-        <p:nvSpPr>
-          <p:cNvPr id="3" name="TextBox 2"/>
-          <p:cNvSpPr txBox="1"/>
-          <p:nvPr/>
-        </p:nvSpPr>
-        <p:spPr>
-          <a:xfrm>
-            <a:off x="1828800" y="2743200"/>
-            <a:ext cx="8229600" cy="1828800"/>
-          </a:xfrm>
-          <a:prstGeom prst="rect">
-            <a:avLst/>
-          </a:prstGeom>
-          <a:noFill/>
-        </p:spPr>
-        <p:txBody>
-          <a:bodyPr wrap="none">
-            <a:spAutoFit/>
-          </a:bodyPr>
-          <a:lstStyle/>
-          <a:p>
-            <a:pPr algn="ctr">
-              <a:defRPr sz="4400" b="1">
-                <a:solidFill>
-                  <a:srgbClr val="2C3E50"/>
-                </a:solidFill>
-              </a:defRPr>
-            </a:pPr>
-            <a:r>
-              <a:t>Thank You</a:t>
-            </a:r>
-          </a:p>
-          <a:p/>
-          <a:p>
-            <a:pPr algn="ctr">
-              <a:defRPr sz="2800">
-                <a:solidFill>
-                  <a:srgbClr val="7F8C8D"/>
-                </a:solidFill>
-              </a:defRPr>
-            </a:pPr>
-            <a:r>
-              <a:t>Questions?</a:t>
             </a:r>
           </a:p>
         </p:txBody>
@@ -5113,7 +4867,7 @@
 </file>
 
 <file path=ppt/slides/slide3.xml><?xml version="1.0" encoding="utf-8"?>
-<p:sld xmlns:a="http://schemas.openxmlformats.org/drawingml/2006/main" xmlns:p="http://schemas.openxmlformats.org/presentationml/2006/main" xmlns:r="http://schemas.openxmlformats.org/officeDocument/2006/relationships">
+<p:sld xmlns:a="http://schemas.openxmlformats.org/drawingml/2006/main" xmlns:r="http://schemas.openxmlformats.org/officeDocument/2006/relationships" xmlns:p="http://schemas.openxmlformats.org/presentationml/2006/main">
   <p:cSld>
     <p:spTree>
       <p:nvGrpSpPr>
@@ -5121,24 +4875,14 @@
         <p:cNvGrpSpPr/>
         <p:nvPr/>
       </p:nvGrpSpPr>
-      <p:grpSpPr/>
-      <p:sp>
-        <p:nvSpPr>
-          <p:cNvPr id="2" name="Title 1"/>
-          <p:cNvSpPr>
-            <a:spLocks noGrp="1"/>
-          </p:cNvSpPr>
-          <p:nvPr>
-            <p:ph type="title"/>
-          </p:nvPr>
-        </p:nvSpPr>
-        <p:spPr/>
-        <p:txBody>
-          <a:bodyPr/>
-          <a:lstStyle/>
-          <a:p/>
-        </p:txBody>
-      </p:sp>
+      <p:grpSpPr>
+        <a:xfrm>
+          <a:off x="0" y="0"/>
+          <a:ext cx="0" cy="0"/>
+          <a:chOff x="0" y="0"/>
+          <a:chExt cx="0" cy="0"/>
+        </a:xfrm>
+      </p:grpSpPr>
       <p:sp>
         <p:nvSpPr>
           <p:cNvPr id="3" name="TextBox 2"/>
@@ -5183,7 +4927,7 @@
         <p:spPr>
           <a:xfrm>
             <a:off x="457200" y="1371600"/>
-            <a:ext cx="10972800" cy="5029200"/>
+            <a:ext cx="10972800" cy="3016210"/>
           </a:xfrm>
           <a:prstGeom prst="rect">
             <a:avLst/>
@@ -5203,6 +4947,7 @@
               <a:defRPr sz="1800"/>
             </a:pPr>
             <a:r>
+              <a:rPr sz="2000" dirty="0"/>
               <a:t>• Glaucoma: irreversible blindness affecting 80M+ globally</a:t>
             </a:r>
           </a:p>
@@ -5214,6 +4959,7 @@
               <a:defRPr sz="1800"/>
             </a:pPr>
             <a:r>
+              <a:rPr sz="2000" dirty="0"/>
               <a:t>• Part 1 trained 3D CNNs on 1,110 OCT volumes (best AUC = 0.94)</a:t>
             </a:r>
           </a:p>
@@ -5225,6 +4971,7 @@
               <a:defRPr sz="1800"/>
             </a:pPr>
             <a:r>
+              <a:rPr sz="2000" dirty="0"/>
               <a:t>• Question: Can data augmentation push performance higher?</a:t>
             </a:r>
           </a:p>
@@ -5236,6 +4983,7 @@
               <a:defRPr sz="1800"/>
             </a:pPr>
             <a:r>
+              <a:rPr sz="2000" dirty="0"/>
               <a:t>• Original paper also tested augmentation (AUC dropped 0.94 → 0.92)</a:t>
             </a:r>
           </a:p>
@@ -5247,6 +4995,7 @@
               <a:defRPr sz="1800"/>
             </a:pPr>
             <a:r>
+              <a:rPr sz="2000" dirty="0"/>
               <a:t>• Our hypothesis: physics-informed augmentation may do better</a:t>
             </a:r>
           </a:p>
@@ -5257,16 +5006,26 @@
               </a:spcAft>
               <a:defRPr sz="1800"/>
             </a:pPr>
-          </a:p>
-          <a:p>
-            <a:pPr>
-              <a:spcAft>
-                <a:spcPts val="1000"/>
-              </a:spcAft>
-              <a:defRPr sz="1800"/>
-            </a:pPr>
-            <a:r>
-              <a:t>Reference: Maetschke et al. (2019), PLOS ONE</a:t>
+            <a:endParaRPr sz="2000" dirty="0"/>
+          </a:p>
+          <a:p>
+            <a:pPr>
+              <a:spcAft>
+                <a:spcPts val="1000"/>
+              </a:spcAft>
+              <a:defRPr sz="1800"/>
+            </a:pPr>
+            <a:r>
+              <a:rPr sz="2000" dirty="0"/>
+              <a:t>Reference: </a:t>
+            </a:r>
+            <a:r>
+              <a:rPr sz="2000" dirty="0" err="1"/>
+              <a:t>Maetschke</a:t>
+            </a:r>
+            <a:r>
+              <a:rPr sz="2000" dirty="0"/>
+              <a:t> et al. (2019), PLOS ONE</a:t>
             </a:r>
           </a:p>
         </p:txBody>
@@ -5280,7 +5039,7 @@
 </file>
 
 <file path=ppt/slides/slide4.xml><?xml version="1.0" encoding="utf-8"?>
-<p:sld xmlns:a="http://schemas.openxmlformats.org/drawingml/2006/main" xmlns:p="http://schemas.openxmlformats.org/presentationml/2006/main" xmlns:r="http://schemas.openxmlformats.org/officeDocument/2006/relationships">
+<p:sld xmlns:a="http://schemas.openxmlformats.org/drawingml/2006/main" xmlns:r="http://schemas.openxmlformats.org/officeDocument/2006/relationships" xmlns:p="http://schemas.openxmlformats.org/presentationml/2006/main">
   <p:cSld>
     <p:spTree>
       <p:nvGrpSpPr>
@@ -5288,24 +5047,14 @@
         <p:cNvGrpSpPr/>
         <p:nvPr/>
       </p:nvGrpSpPr>
-      <p:grpSpPr/>
-      <p:sp>
-        <p:nvSpPr>
-          <p:cNvPr id="2" name="Title 1"/>
-          <p:cNvSpPr>
-            <a:spLocks noGrp="1"/>
-          </p:cNvSpPr>
-          <p:nvPr>
-            <p:ph type="title"/>
-          </p:nvPr>
-        </p:nvSpPr>
-        <p:spPr/>
-        <p:txBody>
-          <a:bodyPr/>
-          <a:lstStyle/>
-          <a:p/>
-        </p:txBody>
-      </p:sp>
+      <p:grpSpPr>
+        <a:xfrm>
+          <a:off x="0" y="0"/>
+          <a:ext cx="0" cy="0"/>
+          <a:chOff x="0" y="0"/>
+          <a:chExt cx="0" cy="0"/>
+        </a:xfrm>
+      </p:grpSpPr>
       <p:sp>
         <p:nvSpPr>
           <p:cNvPr id="3" name="TextBox 2"/>
@@ -5350,7 +5099,7 @@
         <p:spPr>
           <a:xfrm>
             <a:off x="457200" y="1371600"/>
-            <a:ext cx="10972800" cy="5029200"/>
+            <a:ext cx="10972800" cy="2580194"/>
           </a:xfrm>
           <a:prstGeom prst="rect">
             <a:avLst/>
@@ -5370,17 +5119,27 @@
               <a:defRPr sz="1800"/>
             </a:pPr>
             <a:r>
-              <a:t>• Source: Zenodo (Ishikawa, 2018)</a:t>
-            </a:r>
-          </a:p>
-          <a:p>
-            <a:pPr>
-              <a:spcAft>
-                <a:spcPts val="1000"/>
-              </a:spcAft>
-              <a:defRPr sz="1800"/>
-            </a:pPr>
-            <a:r>
+              <a:rPr sz="2000" dirty="0"/>
+              <a:t>• Source: </a:t>
+            </a:r>
+            <a:r>
+              <a:rPr sz="2000" dirty="0" err="1"/>
+              <a:t>Zenodo</a:t>
+            </a:r>
+            <a:r>
+              <a:rPr sz="2000" dirty="0"/>
+              <a:t> (Ishikawa, 2018)</a:t>
+            </a:r>
+          </a:p>
+          <a:p>
+            <a:pPr>
+              <a:spcAft>
+                <a:spcPts val="1000"/>
+              </a:spcAft>
+              <a:defRPr sz="1800"/>
+            </a:pPr>
+            <a:r>
+              <a:rPr sz="2000" dirty="0"/>
               <a:t>• 1,110 ONH-centered OCT volume scans (64×128×64 voxels)</a:t>
             </a:r>
           </a:p>
@@ -5392,6 +5151,7 @@
               <a:defRPr sz="1800"/>
             </a:pPr>
             <a:r>
+              <a:rPr sz="2000" dirty="0"/>
               <a:t>• 624 patients, single Cirrus SD-OCT scanner</a:t>
             </a:r>
           </a:p>
@@ -5403,6 +5163,7 @@
               <a:defRPr sz="1800"/>
             </a:pPr>
             <a:r>
+              <a:rPr sz="2000" dirty="0"/>
               <a:t>• 847 Glaucoma (POAG) / 263 Normal (76% / 24%)</a:t>
             </a:r>
           </a:p>
@@ -5414,6 +5175,7 @@
               <a:defRPr sz="1800"/>
             </a:pPr>
             <a:r>
+              <a:rPr sz="2000" dirty="0"/>
               <a:t>• Same train/test split as Part 1 preserved</a:t>
             </a:r>
           </a:p>
@@ -5425,6 +5187,7 @@
               <a:defRPr sz="1800"/>
             </a:pPr>
             <a:r>
+              <a:rPr sz="2000" dirty="0"/>
               <a:t>• Class distribution kept unbalanced (lesson from Part 1)</a:t>
             </a:r>
           </a:p>
@@ -5439,7 +5202,7 @@
 </file>
 
 <file path=ppt/slides/slide5.xml><?xml version="1.0" encoding="utf-8"?>
-<p:sld xmlns:a="http://schemas.openxmlformats.org/drawingml/2006/main" xmlns:p="http://schemas.openxmlformats.org/presentationml/2006/main" xmlns:r="http://schemas.openxmlformats.org/officeDocument/2006/relationships">
+<p:sld xmlns:a="http://schemas.openxmlformats.org/drawingml/2006/main" xmlns:r="http://schemas.openxmlformats.org/officeDocument/2006/relationships" xmlns:p="http://schemas.openxmlformats.org/presentationml/2006/main">
   <p:cSld>
     <p:spTree>
       <p:nvGrpSpPr>
@@ -5447,24 +5210,14 @@
         <p:cNvGrpSpPr/>
         <p:nvPr/>
       </p:nvGrpSpPr>
-      <p:grpSpPr/>
-      <p:sp>
-        <p:nvSpPr>
-          <p:cNvPr id="2" name="Title 1"/>
-          <p:cNvSpPr>
-            <a:spLocks noGrp="1"/>
-          </p:cNvSpPr>
-          <p:nvPr>
-            <p:ph type="title"/>
-          </p:nvPr>
-        </p:nvSpPr>
-        <p:spPr/>
-        <p:txBody>
-          <a:bodyPr/>
-          <a:lstStyle/>
-          <a:p/>
-        </p:txBody>
-      </p:sp>
+      <p:grpSpPr>
+        <a:xfrm>
+          <a:off x="0" y="0"/>
+          <a:ext cx="0" cy="0"/>
+          <a:chOff x="0" y="0"/>
+          <a:chExt cx="0" cy="0"/>
+        </a:xfrm>
+      </p:grpSpPr>
       <p:sp>
         <p:nvSpPr>
           <p:cNvPr id="3" name="TextBox 2"/>
@@ -5509,7 +5262,7 @@
         <p:spPr>
           <a:xfrm>
             <a:off x="457200" y="1371600"/>
-            <a:ext cx="5029200" cy="4572000"/>
+            <a:ext cx="5029200" cy="2041585"/>
           </a:xfrm>
           <a:prstGeom prst="rect">
             <a:avLst/>
@@ -5529,6 +5282,7 @@
               <a:defRPr sz="1600"/>
             </a:pPr>
             <a:r>
+              <a:rPr sz="2000" dirty="0"/>
               <a:t>• High intra-class SSIM (&gt; 0.8)</a:t>
             </a:r>
           </a:p>
@@ -5540,6 +5294,7 @@
               <a:defRPr sz="1600"/>
             </a:pPr>
             <a:r>
+              <a:rPr sz="2000" dirty="0"/>
               <a:t>• Narrow distribution → conservative</a:t>
             </a:r>
           </a:p>
@@ -5551,6 +5306,7 @@
               <a:defRPr sz="1600"/>
             </a:pPr>
             <a:r>
+              <a:rPr sz="2000" dirty="0"/>
               <a:t>   augmentation parameters</a:t>
             </a:r>
           </a:p>
@@ -5562,6 +5318,7 @@
               <a:defRPr sz="1600"/>
             </a:pPr>
             <a:r>
+              <a:rPr sz="2000" dirty="0"/>
               <a:t>• Augmented volumes must stay</a:t>
             </a:r>
           </a:p>
@@ -5573,6 +5330,7 @@
               <a:defRPr sz="1600"/>
             </a:pPr>
             <a:r>
+              <a:rPr sz="2000" dirty="0"/>
               <a:t>   within natural data manifold</a:t>
             </a:r>
           </a:p>
@@ -5611,7 +5369,7 @@
 </file>
 
 <file path=ppt/slides/slide6.xml><?xml version="1.0" encoding="utf-8"?>
-<p:sld xmlns:a="http://schemas.openxmlformats.org/drawingml/2006/main" xmlns:p="http://schemas.openxmlformats.org/presentationml/2006/main" xmlns:r="http://schemas.openxmlformats.org/officeDocument/2006/relationships">
+<p:sld xmlns:a="http://schemas.openxmlformats.org/drawingml/2006/main" xmlns:r="http://schemas.openxmlformats.org/officeDocument/2006/relationships" xmlns:p="http://schemas.openxmlformats.org/presentationml/2006/main">
   <p:cSld>
     <p:spTree>
       <p:nvGrpSpPr>
@@ -5619,24 +5377,14 @@
         <p:cNvGrpSpPr/>
         <p:nvPr/>
       </p:nvGrpSpPr>
-      <p:grpSpPr/>
-      <p:sp>
-        <p:nvSpPr>
-          <p:cNvPr id="2" name="Title 1"/>
-          <p:cNvSpPr>
-            <a:spLocks noGrp="1"/>
-          </p:cNvSpPr>
-          <p:nvPr>
-            <p:ph type="title"/>
-          </p:nvPr>
-        </p:nvSpPr>
-        <p:spPr/>
-        <p:txBody>
-          <a:bodyPr/>
-          <a:lstStyle/>
-          <a:p/>
-        </p:txBody>
-      </p:sp>
+      <p:grpSpPr>
+        <a:xfrm>
+          <a:off x="0" y="0"/>
+          <a:ext cx="0" cy="0"/>
+          <a:chOff x="0" y="0"/>
+          <a:chExt cx="0" cy="0"/>
+        </a:xfrm>
+      </p:grpSpPr>
       <p:sp>
         <p:nvSpPr>
           <p:cNvPr id="3" name="TextBox 2"/>
@@ -5680,8 +5428,8 @@
         </p:nvSpPr>
         <p:spPr>
           <a:xfrm>
-            <a:off x="457200" y="1371600"/>
-            <a:ext cx="5029200" cy="4572000"/>
+            <a:off x="487680" y="1371600"/>
+            <a:ext cx="5071872" cy="2862322"/>
           </a:xfrm>
           <a:prstGeom prst="rect">
             <a:avLst/>
@@ -5701,6 +5449,7 @@
               <a:defRPr sz="1600"/>
             </a:pPr>
             <a:r>
+              <a:rPr sz="2000" dirty="0"/>
               <a:t>• Glaucoma changes: mid-frequency</a:t>
             </a:r>
           </a:p>
@@ -5712,6 +5461,7 @@
               <a:defRPr sz="1600"/>
             </a:pPr>
             <a:r>
+              <a:rPr sz="2000" dirty="0"/>
               <a:t>• Normal vs Glaucoma similar at</a:t>
             </a:r>
           </a:p>
@@ -5723,6 +5473,7 @@
               <a:defRPr sz="1600"/>
             </a:pPr>
             <a:r>
+              <a:rPr sz="2000" dirty="0"/>
               <a:t>   low &amp; high frequencies</a:t>
             </a:r>
           </a:p>
@@ -5734,6 +5485,7 @@
               <a:defRPr sz="1600"/>
             </a:pPr>
             <a:r>
+              <a:rPr sz="2000" dirty="0"/>
               <a:t>• Informed LPF radius (r=30)</a:t>
             </a:r>
           </a:p>
@@ -5745,8 +5497,28 @@
               <a:defRPr sz="1600"/>
             </a:pPr>
             <a:r>
+              <a:rPr sz="2000" dirty="0"/>
               <a:t>   to preserve diagnostic content</a:t>
             </a:r>
+            <a:endParaRPr lang="en-US" sz="2000" dirty="0"/>
+          </a:p>
+          <a:p>
+            <a:pPr>
+              <a:spcAft>
+                <a:spcPts val="800"/>
+              </a:spcAft>
+              <a:defRPr sz="1600"/>
+            </a:pPr>
+            <a:endParaRPr lang="en-US" sz="2000" dirty="0"/>
+          </a:p>
+          <a:p>
+            <a:pPr>
+              <a:spcAft>
+                <a:spcPts val="800"/>
+              </a:spcAft>
+              <a:defRPr sz="1600"/>
+            </a:pPr>
+            <a:endParaRPr sz="2000" dirty="0"/>
           </a:p>
         </p:txBody>
       </p:sp>
@@ -5783,7 +5555,7 @@
 </file>
 
 <file path=ppt/slides/slide7.xml><?xml version="1.0" encoding="utf-8"?>
-<p:sld xmlns:a="http://schemas.openxmlformats.org/drawingml/2006/main" xmlns:p="http://schemas.openxmlformats.org/presentationml/2006/main" xmlns:r="http://schemas.openxmlformats.org/officeDocument/2006/relationships">
+<p:sld xmlns:a="http://schemas.openxmlformats.org/drawingml/2006/main" xmlns:r="http://schemas.openxmlformats.org/officeDocument/2006/relationships" xmlns:p="http://schemas.openxmlformats.org/presentationml/2006/main">
   <p:cSld>
     <p:spTree>
       <p:nvGrpSpPr>
@@ -5791,24 +5563,14 @@
         <p:cNvGrpSpPr/>
         <p:nvPr/>
       </p:nvGrpSpPr>
-      <p:grpSpPr/>
-      <p:sp>
-        <p:nvSpPr>
-          <p:cNvPr id="2" name="Title 1"/>
-          <p:cNvSpPr>
-            <a:spLocks noGrp="1"/>
-          </p:cNvSpPr>
-          <p:nvPr>
-            <p:ph type="title"/>
-          </p:nvPr>
-        </p:nvSpPr>
-        <p:spPr/>
-        <p:txBody>
-          <a:bodyPr/>
-          <a:lstStyle/>
-          <a:p/>
-        </p:txBody>
-      </p:sp>
+      <p:grpSpPr>
+        <a:xfrm>
+          <a:off x="0" y="0"/>
+          <a:ext cx="0" cy="0"/>
+          <a:chOff x="0" y="0"/>
+          <a:chExt cx="0" cy="0"/>
+        </a:xfrm>
+      </p:grpSpPr>
       <p:sp>
         <p:nvSpPr>
           <p:cNvPr id="3" name="TextBox 2"/>
@@ -5877,7 +5639,7 @@
 </file>
 
 <file path=ppt/slides/slide8.xml><?xml version="1.0" encoding="utf-8"?>
-<p:sld xmlns:a="http://schemas.openxmlformats.org/drawingml/2006/main" xmlns:p="http://schemas.openxmlformats.org/presentationml/2006/main" xmlns:r="http://schemas.openxmlformats.org/officeDocument/2006/relationships">
+<p:sld xmlns:a="http://schemas.openxmlformats.org/drawingml/2006/main" xmlns:r="http://schemas.openxmlformats.org/officeDocument/2006/relationships" xmlns:p="http://schemas.openxmlformats.org/presentationml/2006/main">
   <p:cSld>
     <p:spTree>
       <p:nvGrpSpPr>
@@ -5885,24 +5647,14 @@
         <p:cNvGrpSpPr/>
         <p:nvPr/>
       </p:nvGrpSpPr>
-      <p:grpSpPr/>
-      <p:sp>
-        <p:nvSpPr>
-          <p:cNvPr id="2" name="Title 1"/>
-          <p:cNvSpPr>
-            <a:spLocks noGrp="1"/>
-          </p:cNvSpPr>
-          <p:nvPr>
-            <p:ph type="title"/>
-          </p:nvPr>
-        </p:nvSpPr>
-        <p:spPr/>
-        <p:txBody>
-          <a:bodyPr/>
-          <a:lstStyle/>
-          <a:p/>
-        </p:txBody>
-      </p:sp>
+      <p:grpSpPr>
+        <a:xfrm>
+          <a:off x="0" y="0"/>
+          <a:ext cx="0" cy="0"/>
+          <a:chOff x="0" y="0"/>
+          <a:chExt cx="0" cy="0"/>
+        </a:xfrm>
+      </p:grpSpPr>
       <p:sp>
         <p:nvSpPr>
           <p:cNvPr id="3" name="TextBox 2"/>
@@ -5971,7 +5723,7 @@
 </file>
 
 <file path=ppt/slides/slide9.xml><?xml version="1.0" encoding="utf-8"?>
-<p:sld xmlns:a="http://schemas.openxmlformats.org/drawingml/2006/main" xmlns:p="http://schemas.openxmlformats.org/presentationml/2006/main" xmlns:r="http://schemas.openxmlformats.org/officeDocument/2006/relationships">
+<p:sld xmlns:a="http://schemas.openxmlformats.org/drawingml/2006/main" xmlns:r="http://schemas.openxmlformats.org/officeDocument/2006/relationships" xmlns:p="http://schemas.openxmlformats.org/presentationml/2006/main">
   <p:cSld>
     <p:spTree>
       <p:nvGrpSpPr>
@@ -5979,24 +5731,14 @@
         <p:cNvGrpSpPr/>
         <p:nvPr/>
       </p:nvGrpSpPr>
-      <p:grpSpPr/>
-      <p:sp>
-        <p:nvSpPr>
-          <p:cNvPr id="2" name="Title 1"/>
-          <p:cNvSpPr>
-            <a:spLocks noGrp="1"/>
-          </p:cNvSpPr>
-          <p:nvPr>
-            <p:ph type="title"/>
-          </p:nvPr>
-        </p:nvSpPr>
-        <p:spPr/>
-        <p:txBody>
-          <a:bodyPr/>
-          <a:lstStyle/>
-          <a:p/>
-        </p:txBody>
-      </p:sp>
+      <p:grpSpPr>
+        <a:xfrm>
+          <a:off x="0" y="0"/>
+          <a:ext cx="0" cy="0"/>
+          <a:chOff x="0" y="0"/>
+          <a:chExt cx="0" cy="0"/>
+        </a:xfrm>
+      </p:grpSpPr>
       <p:sp>
         <p:nvSpPr>
           <p:cNvPr id="3" name="TextBox 2"/>
@@ -6041,7 +5783,7 @@
         <p:spPr>
           <a:xfrm>
             <a:off x="457200" y="1371600"/>
-            <a:ext cx="10972800" cy="5029200"/>
+            <a:ext cx="10972800" cy="4293483"/>
           </a:xfrm>
           <a:prstGeom prst="rect">
             <a:avLst/>
@@ -6061,17 +5803,27 @@
               <a:defRPr sz="1800"/>
             </a:pPr>
             <a:r>
-              <a:t>1. Sequential CNN — 5-layer (replicating Maetschke et al., 2019)</a:t>
-            </a:r>
-          </a:p>
-          <a:p>
-            <a:pPr>
-              <a:spcAft>
-                <a:spcPts val="1000"/>
-              </a:spcAft>
-              <a:defRPr sz="1800"/>
-            </a:pPr>
-            <a:r>
+              <a:rPr sz="2000" dirty="0"/>
+              <a:t>1. Sequential CNN — 5-layer (replicating </a:t>
+            </a:r>
+            <a:r>
+              <a:rPr sz="2000" dirty="0" err="1"/>
+              <a:t>Maetschke</a:t>
+            </a:r>
+            <a:r>
+              <a:rPr sz="2000" dirty="0"/>
+              <a:t> et al., 2019)</a:t>
+            </a:r>
+          </a:p>
+          <a:p>
+            <a:pPr>
+              <a:spcAft>
+                <a:spcPts val="1000"/>
+              </a:spcAft>
+              <a:defRPr sz="1800"/>
+            </a:pPr>
+            <a:r>
+              <a:rPr sz="2000" dirty="0"/>
               <a:t>     Kernels: 7-5-5-3-3, 32 filters each</a:t>
             </a:r>
           </a:p>
@@ -6082,26 +5834,37 @@
               </a:spcAft>
               <a:defRPr sz="1800"/>
             </a:pPr>
-          </a:p>
-          <a:p>
-            <a:pPr>
-              <a:spcAft>
-                <a:spcPts val="1000"/>
-              </a:spcAft>
-              <a:defRPr sz="1800"/>
-            </a:pPr>
-            <a:r>
-              <a:t>2. ResNet-Like — Residual skip connections</a:t>
-            </a:r>
-          </a:p>
-          <a:p>
-            <a:pPr>
-              <a:spcAft>
-                <a:spcPts val="1000"/>
-              </a:spcAft>
-              <a:defRPr sz="1800"/>
-            </a:pPr>
-            <a:r>
+            <a:endParaRPr sz="2000" dirty="0"/>
+          </a:p>
+          <a:p>
+            <a:pPr>
+              <a:spcAft>
+                <a:spcPts val="1000"/>
+              </a:spcAft>
+              <a:defRPr sz="1800"/>
+            </a:pPr>
+            <a:r>
+              <a:rPr sz="2000" dirty="0"/>
+              <a:t>2. </a:t>
+            </a:r>
+            <a:r>
+              <a:rPr sz="2000" dirty="0" err="1"/>
+              <a:t>ResNet</a:t>
+            </a:r>
+            <a:r>
+              <a:rPr sz="2000" dirty="0"/>
+              <a:t>-Like — Residual skip connections</a:t>
+            </a:r>
+          </a:p>
+          <a:p>
+            <a:pPr>
+              <a:spcAft>
+                <a:spcPts val="1000"/>
+              </a:spcAft>
+              <a:defRPr sz="1800"/>
+            </a:pPr>
+            <a:r>
+              <a:rPr sz="2000" dirty="0"/>
               <a:t>     Conv3D stem + 3 residual blocks</a:t>
             </a:r>
           </a:p>
@@ -6112,15 +5875,17 @@
               </a:spcAft>
               <a:defRPr sz="1800"/>
             </a:pPr>
-          </a:p>
-          <a:p>
-            <a:pPr>
-              <a:spcAft>
-                <a:spcPts val="1000"/>
-              </a:spcAft>
-              <a:defRPr sz="1800"/>
-            </a:pPr>
-            <a:r>
+            <a:endParaRPr sz="2000" dirty="0"/>
+          </a:p>
+          <a:p>
+            <a:pPr>
+              <a:spcAft>
+                <a:spcPts val="1000"/>
+              </a:spcAft>
+              <a:defRPr sz="1800"/>
+            </a:pPr>
+            <a:r>
+              <a:rPr sz="2000" dirty="0"/>
               <a:t>3. Attention — SE + spatial attention blocks</a:t>
             </a:r>
           </a:p>
@@ -6132,6 +5897,7 @@
               <a:defRPr sz="1800"/>
             </a:pPr>
             <a:r>
+              <a:rPr sz="2000" dirty="0"/>
               <a:t>     Channel &amp; spatial feature recalibration</a:t>
             </a:r>
           </a:p>
@@ -6142,16 +5908,26 @@
               </a:spcAft>
               <a:defRPr sz="1800"/>
             </a:pPr>
-          </a:p>
-          <a:p>
-            <a:pPr>
-              <a:spcAft>
-                <a:spcPts val="1000"/>
-              </a:spcAft>
-              <a:defRPr sz="1800"/>
-            </a:pPr>
-            <a:r>
-              <a:t>All: GAP3D → Dense(1, sigmoid) | NAdam | Binary CE</a:t>
+            <a:endParaRPr sz="2000" dirty="0"/>
+          </a:p>
+          <a:p>
+            <a:pPr>
+              <a:spcAft>
+                <a:spcPts val="1000"/>
+              </a:spcAft>
+              <a:defRPr sz="1800"/>
+            </a:pPr>
+            <a:r>
+              <a:rPr sz="2000" dirty="0"/>
+              <a:t>All: GAP3D → Dense(1, sigmoid) | </a:t>
+            </a:r>
+            <a:r>
+              <a:rPr sz="2000" dirty="0" err="1"/>
+              <a:t>NAdam</a:t>
+            </a:r>
+            <a:r>
+              <a:rPr sz="2000" dirty="0"/>
+              <a:t> | Binary CE</a:t>
             </a:r>
           </a:p>
         </p:txBody>

</xml_diff>